<commit_message>
Rebuild the deck around the three roles and three protocols
The README's framing is better than the one the deck was built on, so
the deck follows it: Owner, User and Controller as separate roles, and
NWC, NCC and NSC as separate protocols over one transport.

Adds the architecture diagram as its own slide, inverted for the dark
theme — the enclave box comes out in the accent colour, which is a
happy accident.

The point that carries the whole argument is now stated as its own
slide: a user or controller cannot make the signer approve an operation
outside the Owner's policy merely by controlling dln-node.
</commit_message>
<xml_diff>
--- a/doc/diamond-lightning-node.pptx
+++ b/doc/diamond-lightning-node.pptx
@@ -3257,7 +3257,7 @@
                 </a:solidFill>
                 <a:latin typeface="Arial"/>
               </a:rPr>
-              <a:t>A Lightning node with no API, no keys,</a:t>
+              <a:t>A Lightning node that is not trusted —</a:t>
             </a:r>
           </a:p>
           <a:p>
@@ -3273,7 +3273,7 @@
                 </a:solidFill>
                 <a:latin typeface="Arial"/>
               </a:rPr>
-              <a:t>and no trust placed in itself</a:t>
+              <a:t>not even by itself</a:t>
             </a:r>
           </a:p>
         </p:txBody>
@@ -3524,7 +3524,7 @@
                 </a:solidFill>
                 <a:latin typeface="Arial"/>
               </a:rPr>
-              <a:t>—   Compromise the host and you have the interface and the money</a:t>
+              <a:t>—   Whoever controls the node controls the money</a:t>
             </a:r>
           </a:p>
         </p:txBody>
@@ -3664,21 +3664,45 @@
                 </a:solidFill>
                 <a:latin typeface="Arial"/>
               </a:rPr>
-              <a:t>WHAT WE BUILT INSTEAD</a:t>
-            </a:r>
-          </a:p>
-        </p:txBody>
-      </p:sp>
-      <p:sp>
-        <p:nvSpPr>
-          <p:cNvPr id="4" name="TextBox 3"/>
+              <a:t>THE ARCHITECTURE</a:t>
+            </a:r>
+          </a:p>
+        </p:txBody>
+      </p:sp>
+      <p:pic>
+        <p:nvPicPr>
+          <p:cNvPr id="4" name="Picture 3" descr="design-dark.png"/>
+          <p:cNvPicPr>
+            <a:picLocks noChangeAspect="1"/>
+          </p:cNvPicPr>
+          <p:nvPr/>
+        </p:nvPicPr>
+        <p:blipFill>
+          <a:blip r:embed="rId2"/>
+          <a:stretch>
+            <a:fillRect/>
+          </a:stretch>
+        </p:blipFill>
+        <p:spPr>
+          <a:xfrm>
+            <a:off x="2599829" y="1024128"/>
+            <a:ext cx="6992037" cy="4892040"/>
+          </a:xfrm>
+          <a:prstGeom prst="rect">
+            <a:avLst/>
+          </a:prstGeom>
+        </p:spPr>
+      </p:pic>
+      <p:sp>
+        <p:nvSpPr>
+          <p:cNvPr id="5" name="TextBox 4"/>
           <p:cNvSpPr txBox="1"/>
           <p:nvPr/>
         </p:nvSpPr>
         <p:spPr>
           <a:xfrm>
-            <a:off x="822960" y="1051560"/>
-            <a:ext cx="10515600" cy="1280160"/>
+            <a:off x="822960" y="5989320"/>
+            <a:ext cx="10515600" cy="457200"/>
           </a:xfrm>
           <a:prstGeom prst="rect">
             <a:avLst/>
@@ -3697,171 +3721,13 @@
               </a:spcAft>
             </a:pPr>
             <a:r>
-              <a:rPr sz="4000" b="1" i="0">
-                <a:solidFill>
-                  <a:srgbClr val="E8EDF2"/>
-                </a:solidFill>
-                <a:latin typeface="Arial"/>
-              </a:rPr>
-              <a:t>Three properties, chosen deliberately</a:t>
-            </a:r>
-          </a:p>
-        </p:txBody>
-      </p:sp>
-      <p:sp>
-        <p:nvSpPr>
-          <p:cNvPr id="5" name="TextBox 4"/>
-          <p:cNvSpPr txBox="1"/>
-          <p:nvPr/>
-        </p:nvSpPr>
-        <p:spPr>
-          <a:xfrm>
-            <a:off x="822960" y="2286000"/>
-            <a:ext cx="10515600" cy="3840480"/>
-          </a:xfrm>
-          <a:prstGeom prst="rect">
-            <a:avLst/>
-          </a:prstGeom>
-          <a:noFill/>
-        </p:spPr>
-        <p:txBody>
-          <a:bodyPr wrap="square" lIns="0" rIns="0" tIns="0" bIns="0">
-            <a:spAutoFit/>
-          </a:bodyPr>
-          <a:lstStyle/>
-          <a:p>
-            <a:pPr>
-              <a:spcAft>
-                <a:spcPts val="600"/>
-              </a:spcAft>
-            </a:pPr>
-            <a:r>
-              <a:rPr sz="2000" b="1" i="0">
-                <a:solidFill>
-                  <a:srgbClr val="7FD8E8"/>
-                </a:solidFill>
-                <a:latin typeface="Arial"/>
-              </a:rPr>
-              <a:t>Transparent</a:t>
-            </a:r>
-          </a:p>
-          <a:p>
-            <a:pPr>
-              <a:spcAft>
-                <a:spcPts val="600"/>
-              </a:spcAft>
-            </a:pPr>
-            <a:r>
-              <a:rPr sz="1800" b="0" i="0">
+              <a:rPr sz="1400" b="0" i="1">
                 <a:solidFill>
                   <a:srgbClr val="8A97A3"/>
                 </a:solidFill>
                 <a:latin typeface="Arial"/>
               </a:rPr>
-              <a:t>User-auditable, under GPL-3. Nothing to take on faith.</a:t>
-            </a:r>
-          </a:p>
-          <a:p>
-            <a:pPr>
-              <a:spcAft>
-                <a:spcPts val="600"/>
-              </a:spcAft>
-            </a:pPr>
-            <a:r>
-              <a:rPr sz="2000" b="1" i="0">
-                <a:solidFill>
-                  <a:srgbClr val="7FD8E8"/>
-                </a:solidFill>
-                <a:latin typeface="Arial"/>
-              </a:rPr>
-              <a:t>Hard</a:t>
-            </a:r>
-          </a:p>
-          <a:p>
-            <a:pPr>
-              <a:spcAft>
-                <a:spcPts val="600"/>
-              </a:spcAft>
-            </a:pPr>
-            <a:r>
-              <a:rPr sz="1800" b="0" i="0">
-                <a:solidFill>
-                  <a:srgbClr val="8A97A3"/>
-                </a:solidFill>
-                <a:latin typeface="Arial"/>
-              </a:rPr>
-              <a:t>Low attack surface, minimal, defensive, functional design.</a:t>
-            </a:r>
-          </a:p>
-          <a:p>
-            <a:pPr>
-              <a:spcAft>
-                <a:spcPts val="600"/>
-              </a:spcAft>
-            </a:pPr>
-            <a:r>
-              <a:rPr sz="2000" b="1" i="0">
-                <a:solidFill>
-                  <a:srgbClr val="7FD8E8"/>
-                </a:solidFill>
-                <a:latin typeface="Arial"/>
-              </a:rPr>
-              <a:t>Controlled</a:t>
-            </a:r>
-          </a:p>
-          <a:p>
-            <a:pPr>
-              <a:spcAft>
-                <a:spcPts val="600"/>
-              </a:spcAft>
-            </a:pPr>
-            <a:r>
-              <a:rPr sz="1800" b="0" i="0">
-                <a:solidFill>
-                  <a:srgbClr val="8A97A3"/>
-                </a:solidFill>
-                <a:latin typeface="Arial"/>
-              </a:rPr>
-              <a:t>A process from commit to review to deployment.</a:t>
-            </a:r>
-          </a:p>
-        </p:txBody>
-      </p:sp>
-      <p:sp>
-        <p:nvSpPr>
-          <p:cNvPr id="6" name="TextBox 5"/>
-          <p:cNvSpPr txBox="1"/>
-          <p:nvPr/>
-        </p:nvSpPr>
-        <p:spPr>
-          <a:xfrm>
-            <a:off x="822960" y="5989320"/>
-            <a:ext cx="10515600" cy="457200"/>
-          </a:xfrm>
-          <a:prstGeom prst="rect">
-            <a:avLst/>
-          </a:prstGeom>
-          <a:noFill/>
-        </p:spPr>
-        <p:txBody>
-          <a:bodyPr wrap="square" lIns="0" rIns="0" tIns="0" bIns="0">
-            <a:spAutoFit/>
-          </a:bodyPr>
-          <a:lstStyle/>
-          <a:p>
-            <a:pPr>
-              <a:spcAft>
-                <a:spcPts val="0"/>
-              </a:spcAft>
-            </a:pPr>
-            <a:r>
-              <a:rPr sz="1400" b="0" i="1">
-                <a:solidFill>
-                  <a:srgbClr val="8A97A3"/>
-                </a:solidFill>
-                <a:latin typeface="Arial"/>
-              </a:rPr>
-              <a:t>Like a diamond: transparent, hard, and made under controlled conditions.</a:t>
+              <a:t>Three roles, three protocols, and a signer the node cannot talk past.</a:t>
             </a:r>
           </a:p>
         </p:txBody>
@@ -3962,7 +3828,7 @@
                 </a:solidFill>
                 <a:latin typeface="Arial"/>
               </a:rPr>
-              <a:t>NO API</a:t>
+              <a:t>SEPARATION OF POWERS</a:t>
             </a:r>
           </a:p>
         </p:txBody>
@@ -4001,7 +3867,7 @@
                 </a:solidFill>
                 <a:latin typeface="Arial"/>
               </a:rPr>
-              <a:t>Nostr is the only control plane</a:t>
+              <a:t>Three roles, and none of them is trusted twice</a:t>
             </a:r>
           </a:p>
         </p:txBody>
@@ -4014,7 +3880,7 @@
         </p:nvSpPr>
         <p:spPr>
           <a:xfrm>
-            <a:off x="822960" y="2331720"/>
+            <a:off x="822960" y="2286000"/>
             <a:ext cx="10515600" cy="3840480"/>
           </a:xfrm>
           <a:prstGeom prst="rect">
@@ -4030,23 +3896,23 @@
           <a:p>
             <a:pPr>
               <a:spcAft>
-                <a:spcPts val="1000"/>
-              </a:spcAft>
-            </a:pPr>
-            <a:r>
-              <a:rPr sz="2000" b="0" i="0">
-                <a:solidFill>
-                  <a:srgbClr val="E8EDF2"/>
-                </a:solidFill>
-                <a:latin typeface="Arial"/>
-              </a:rPr>
-              <a:t>There is no CLI. There is no local socket. Nothing listens for control.</a:t>
-            </a:r>
-          </a:p>
-          <a:p>
-            <a:pPr>
-              <a:spcAft>
-                <a:spcPts val="1000"/>
+                <a:spcPts val="600"/>
+              </a:spcAft>
+            </a:pPr>
+            <a:r>
+              <a:rPr sz="2000" b="1" i="0">
+                <a:solidFill>
+                  <a:srgbClr val="7FD8E8"/>
+                </a:solidFill>
+                <a:latin typeface="Arial"/>
+              </a:rPr>
+              <a:t>Owner</a:t>
+            </a:r>
+          </a:p>
+          <a:p>
+            <a:pPr>
+              <a:spcAft>
+                <a:spcPts val="600"/>
               </a:spcAft>
             </a:pPr>
             <a:r>
@@ -4056,45 +3922,29 @@
                 </a:solidFill>
                 <a:latin typeface="Arial"/>
               </a:rPr>
-              <a:t/>
-            </a:r>
-          </a:p>
-          <a:p>
-            <a:pPr>
-              <a:spcAft>
-                <a:spcPts val="1000"/>
-              </a:spcAft>
-            </a:pPr>
-            <a:r>
-              <a:rPr sz="2000" b="0" i="0">
-                <a:solidFill>
-                  <a:srgbClr val="E8EDF2"/>
-                </a:solidFill>
-                <a:latin typeface="Arial"/>
-              </a:rPr>
-              <a:t>—   NWC — wallet operations: balances, invoices, payments, on-chain</a:t>
-            </a:r>
-          </a:p>
-          <a:p>
-            <a:pPr>
-              <a:spcAft>
-                <a:spcPts val="1000"/>
-              </a:spcAft>
-            </a:pPr>
-            <a:r>
-              <a:rPr sz="2000" b="0" i="0">
-                <a:solidFill>
-                  <a:srgbClr val="E8EDF2"/>
-                </a:solidFill>
-                <a:latin typeface="Arial"/>
-              </a:rPr>
-              <a:t>—   NCC — node operations: channels, peers, fees, routing</a:t>
-            </a:r>
-          </a:p>
-          <a:p>
-            <a:pPr>
-              <a:spcAft>
-                <a:spcPts val="1000"/>
+              <a:t>Defines the signing policy. Touches nothing day to day.</a:t>
+            </a:r>
+          </a:p>
+          <a:p>
+            <a:pPr>
+              <a:spcAft>
+                <a:spcPts val="600"/>
+              </a:spcAft>
+            </a:pPr>
+            <a:r>
+              <a:rPr sz="2000" b="1" i="0">
+                <a:solidFill>
+                  <a:srgbClr val="7FD8E8"/>
+                </a:solidFill>
+                <a:latin typeface="Arial"/>
+              </a:rPr>
+              <a:t>User</a:t>
+            </a:r>
+          </a:p>
+          <a:p>
+            <a:pPr>
+              <a:spcAft>
+                <a:spcPts val="600"/>
               </a:spcAft>
             </a:pPr>
             <a:r>
@@ -4104,13 +3954,13 @@
                 </a:solidFill>
                 <a:latin typeface="Arial"/>
               </a:rPr>
-              <a:t/>
-            </a:r>
-          </a:p>
-          <a:p>
-            <a:pPr>
-              <a:spcAft>
-                <a:spcPts val="1000"/>
+              <a:t>Spends through the wallet, within the Owner's permissions and limits.</a:t>
+            </a:r>
+          </a:p>
+          <a:p>
+            <a:pPr>
+              <a:spcAft>
+                <a:spcPts val="600"/>
               </a:spcAft>
             </a:pPr>
             <a:r>
@@ -4120,7 +3970,23 @@
                 </a:solidFill>
                 <a:latin typeface="Arial"/>
               </a:rPr>
-              <a:t>The node reaches out to a relay. It is never reached.</a:t>
+              <a:t>Controller</a:t>
+            </a:r>
+          </a:p>
+          <a:p>
+            <a:pPr>
+              <a:spcAft>
+                <a:spcPts val="600"/>
+              </a:spcAft>
+            </a:pPr>
+            <a:r>
+              <a:rPr sz="1800" b="0" i="0">
+                <a:solidFill>
+                  <a:srgbClr val="8A97A3"/>
+                </a:solidFill>
+                <a:latin typeface="Arial"/>
+              </a:rPr>
+              <a:t>Operates the node — channels, peers, fees — under the same policy.</a:t>
             </a:r>
           </a:p>
         </p:txBody>
@@ -4159,7 +4025,7 @@
                 </a:solidFill>
                 <a:latin typeface="Arial"/>
               </a:rPr>
-              <a:t>Nothing to port-scan. Nothing to leave accidentally exposed.</a:t>
+              <a:t>A role is a key, not an account. Capabilities are granted per key and per method.</a:t>
             </a:r>
           </a:p>
         </p:txBody>
@@ -4260,7 +4126,7 @@
                 </a:solidFill>
                 <a:latin typeface="Arial"/>
               </a:rPr>
-              <a:t>CUSTODY</a:t>
+              <a:t>ONE TRANSPORT, THREE PROTOCOLS</a:t>
             </a:r>
           </a:p>
         </p:txBody>
@@ -4299,7 +4165,7 @@
                 </a:solidFill>
                 <a:latin typeface="Arial"/>
               </a:rPr>
-              <a:t>The node does not hold the keys</a:t>
+              <a:t>Nostr is the only control plane</a:t>
             </a:r>
           </a:p>
         </p:txBody>
@@ -4312,7 +4178,7 @@
         </p:nvSpPr>
         <p:spPr>
           <a:xfrm>
-            <a:off x="822960" y="2331720"/>
+            <a:off x="822960" y="2240280"/>
             <a:ext cx="10515600" cy="3840480"/>
           </a:xfrm>
           <a:prstGeom prst="rect">
@@ -4328,71 +4194,23 @@
           <a:p>
             <a:pPr>
               <a:spcAft>
-                <a:spcPts val="1200"/>
-              </a:spcAft>
-            </a:pPr>
-            <a:r>
-              <a:rPr sz="2000" b="0" i="0">
-                <a:solidFill>
-                  <a:srgbClr val="E8EDF2"/>
-                </a:solidFill>
-                <a:latin typeface="Arial"/>
-              </a:rPr>
-              <a:t>—   Keys live in a separate signing process, reached over a relay</a:t>
-            </a:r>
-          </a:p>
-          <a:p>
-            <a:pPr>
-              <a:spcAft>
-                <a:spcPts val="1200"/>
-              </a:spcAft>
-            </a:pPr>
-            <a:r>
-              <a:rPr sz="2000" b="0" i="0">
-                <a:solidFill>
-                  <a:srgbClr val="E8EDF2"/>
-                </a:solidFill>
-                <a:latin typeface="Arial"/>
-              </a:rPr>
-              <a:t>—   Every signature is a request the signer validates against policy</a:t>
-            </a:r>
-          </a:p>
-          <a:p>
-            <a:pPr>
-              <a:spcAft>
-                <a:spcPts val="1200"/>
-              </a:spcAft>
-            </a:pPr>
-            <a:r>
-              <a:rPr sz="2000" b="0" i="0">
-                <a:solidFill>
-                  <a:srgbClr val="E8EDF2"/>
-                </a:solidFill>
-                <a:latin typeface="Arial"/>
-              </a:rPr>
-              <a:t>—   The signer can refuse — and the node cannot override it</a:t>
-            </a:r>
-          </a:p>
-          <a:p>
-            <a:pPr>
-              <a:spcAft>
-                <a:spcPts val="1200"/>
-              </a:spcAft>
-            </a:pPr>
-            <a:r>
-              <a:rPr sz="2000" b="0" i="0">
-                <a:solidFill>
-                  <a:srgbClr val="E8EDF2"/>
-                </a:solidFill>
-                <a:latin typeface="Arial"/>
-              </a:rPr>
-              <a:t>—   The signer can run inside an attested secure enclave</a:t>
-            </a:r>
-          </a:p>
-          <a:p>
-            <a:pPr>
-              <a:spcAft>
-                <a:spcPts val="1200"/>
+                <a:spcPts val="600"/>
+              </a:spcAft>
+            </a:pPr>
+            <a:r>
+              <a:rPr sz="2000" b="1" i="0">
+                <a:solidFill>
+                  <a:srgbClr val="7FD8E8"/>
+                </a:solidFill>
+                <a:latin typeface="Arial"/>
+              </a:rPr>
+              <a:t>NWC   ·   the wallet</a:t>
+            </a:r>
+          </a:p>
+          <a:p>
+            <a:pPr>
+              <a:spcAft>
+                <a:spcPts val="600"/>
               </a:spcAft>
             </a:pPr>
             <a:r>
@@ -4402,13 +4220,13 @@
                 </a:solidFill>
                 <a:latin typeface="Arial"/>
               </a:rPr>
-              <a:t/>
-            </a:r>
-          </a:p>
-          <a:p>
-            <a:pPr>
-              <a:spcAft>
-                <a:spcPts val="1200"/>
+              <a:t>Invoices, payments, offers, on-chain. Extends NIP-47.</a:t>
+            </a:r>
+          </a:p>
+          <a:p>
+            <a:pPr>
+              <a:spcAft>
+                <a:spcPts val="600"/>
               </a:spcAft>
             </a:pPr>
             <a:r>
@@ -4418,7 +4236,94 @@
                 </a:solidFill>
                 <a:latin typeface="Arial"/>
               </a:rPr>
-              <a:t>Compromising the node does not get you the money.</a:t>
+              <a:t>NCC   ·   the node</a:t>
+            </a:r>
+          </a:p>
+          <a:p>
+            <a:pPr>
+              <a:spcAft>
+                <a:spcPts val="600"/>
+              </a:spcAft>
+            </a:pPr>
+            <a:r>
+              <a:rPr sz="1800" b="0" i="0">
+                <a:solidFill>
+                  <a:srgbClr val="8A97A3"/>
+                </a:solidFill>
+                <a:latin typeface="Arial"/>
+              </a:rPr>
+              <a:t>Channels, peers, fees, routing, network queries.</a:t>
+            </a:r>
+          </a:p>
+          <a:p>
+            <a:pPr>
+              <a:spcAft>
+                <a:spcPts val="600"/>
+              </a:spcAft>
+            </a:pPr>
+            <a:r>
+              <a:rPr sz="2000" b="1" i="0">
+                <a:solidFill>
+                  <a:srgbClr val="7FD8E8"/>
+                </a:solidFill>
+                <a:latin typeface="Arial"/>
+              </a:rPr>
+              <a:t>NSC   ·   the signer</a:t>
+            </a:r>
+          </a:p>
+          <a:p>
+            <a:pPr>
+              <a:spcAft>
+                <a:spcPts val="600"/>
+              </a:spcAft>
+            </a:pPr>
+            <a:r>
+              <a:rPr sz="1800" b="0" i="0">
+                <a:solidFill>
+                  <a:srgbClr val="8A97A3"/>
+                </a:solidFill>
+                <a:latin typeface="Arial"/>
+              </a:rPr>
+              <a:t>Signing requests, and the policy that governs them.</a:t>
+            </a:r>
+          </a:p>
+        </p:txBody>
+      </p:sp>
+      <p:sp>
+        <p:nvSpPr>
+          <p:cNvPr id="6" name="TextBox 5"/>
+          <p:cNvSpPr txBox="1"/>
+          <p:nvPr/>
+        </p:nvSpPr>
+        <p:spPr>
+          <a:xfrm>
+            <a:off x="822960" y="5989320"/>
+            <a:ext cx="10515600" cy="457200"/>
+          </a:xfrm>
+          <a:prstGeom prst="rect">
+            <a:avLst/>
+          </a:prstGeom>
+          <a:noFill/>
+        </p:spPr>
+        <p:txBody>
+          <a:bodyPr wrap="square" lIns="0" rIns="0" tIns="0" bIns="0">
+            <a:spAutoFit/>
+          </a:bodyPr>
+          <a:lstStyle/>
+          <a:p>
+            <a:pPr>
+              <a:spcAft>
+                <a:spcPts val="0"/>
+              </a:spcAft>
+            </a:pPr>
+            <a:r>
+              <a:rPr sz="1400" b="0" i="1">
+                <a:solidFill>
+                  <a:srgbClr val="8A97A3"/>
+                </a:solidFill>
+                <a:latin typeface="Arial"/>
+              </a:rPr>
+              <a:t>No CLI. No local socket. Nothing listens for control — the node reaches out to a relay.</a:t>
             </a:r>
           </a:p>
         </p:txBody>
@@ -4519,7 +4424,7 @@
                 </a:solidFill>
                 <a:latin typeface="Arial"/>
               </a:rPr>
-              <a:t>AUTHORISATION</a:t>
+              <a:t>WHY THE SHAPE MATTERS</a:t>
             </a:r>
           </a:p>
         </p:txBody>
@@ -4552,13 +4457,14 @@
               </a:spcAft>
             </a:pPr>
             <a:r>
-              <a:rPr sz="4000" b="1" i="0">
+              <a:rPr sz="3800" b="1" i="0">
                 <a:solidFill>
                   <a:srgbClr val="E8EDF2"/>
                 </a:solidFill>
                 <a:latin typeface="Arial"/>
               </a:rPr>
-              <a:t>A capability, not a password</a:t>
+              <a:t>Policy lives in the signer,
+not in the node</a:t>
             </a:r>
           </a:p>
         </p:txBody>
@@ -4571,7 +4477,7 @@
         </p:nvSpPr>
         <p:spPr>
           <a:xfrm>
-            <a:off x="822960" y="2286000"/>
+            <a:off x="822960" y="2834640"/>
             <a:ext cx="10515600" cy="3840480"/>
           </a:xfrm>
           <a:prstGeom prst="rect">
@@ -4597,7 +4503,7 @@
                 </a:solidFill>
                 <a:latin typeface="Arial"/>
               </a:rPr>
-              <a:t>Access is granted per method and per client key, as a signed</a:t>
+              <a:t>The keys are not the node's. Every signature is a request the signer</a:t>
             </a:r>
           </a:p>
           <a:p>
@@ -4613,7 +4519,7 @@
                 </a:solidFill>
                 <a:latin typeface="Arial"/>
               </a:rPr>
-              <a:t>Nostr event the node reads from the relay.</a:t>
+              <a:t>validates against the Owner's policy — and can refuse.</a:t>
             </a:r>
           </a:p>
           <a:p>
@@ -4639,77 +4545,61 @@
               </a:spcAft>
             </a:pPr>
             <a:r>
+              <a:rPr sz="2000" b="1" i="0">
+                <a:solidFill>
+                  <a:srgbClr val="7FD8E8"/>
+                </a:solidFill>
+                <a:latin typeface="Arial"/>
+              </a:rPr>
+              <a:t>A user or controller cannot make the signer approve an operation</a:t>
+            </a:r>
+          </a:p>
+          <a:p>
+            <a:pPr>
+              <a:spcAft>
+                <a:spcPts val="800"/>
+              </a:spcAft>
+            </a:pPr>
+            <a:r>
+              <a:rPr sz="2000" b="1" i="0">
+                <a:solidFill>
+                  <a:srgbClr val="7FD8E8"/>
+                </a:solidFill>
+                <a:latin typeface="Arial"/>
+              </a:rPr>
+              <a:t>outside that policy merely by controlling dln-node.</a:t>
+            </a:r>
+          </a:p>
+          <a:p>
+            <a:pPr>
+              <a:spcAft>
+                <a:spcPts val="800"/>
+              </a:spcAft>
+            </a:pPr>
+            <a:r>
+              <a:rPr sz="1800" b="0" i="0">
+                <a:solidFill>
+                  <a:srgbClr val="8A97A3"/>
+                </a:solidFill>
+                <a:latin typeface="Arial"/>
+              </a:rPr>
+              <a:t/>
+            </a:r>
+          </a:p>
+          <a:p>
+            <a:pPr>
+              <a:spcAft>
+                <a:spcPts val="800"/>
+              </a:spcAft>
+            </a:pPr>
+            <a:r>
               <a:rPr sz="2000" b="0" i="0">
                 <a:solidFill>
                   <a:srgbClr val="E8EDF2"/>
                 </a:solidFill>
                 <a:latin typeface="Arial"/>
               </a:rPr>
-              <a:t>—   Different clients hold different powers over the same node</a:t>
-            </a:r>
-          </a:p>
-          <a:p>
-            <a:pPr>
-              <a:spcAft>
-                <a:spcPts val="800"/>
-              </a:spcAft>
-            </a:pPr>
-            <a:r>
-              <a:rPr sz="2000" b="0" i="0">
-                <a:solidFill>
-                  <a:srgbClr val="E8EDF2"/>
-                </a:solidFill>
-                <a:latin typeface="Arial"/>
-              </a:rPr>
-              <a:t>—   Rate limits per method, quotas per client</a:t>
-            </a:r>
-          </a:p>
-          <a:p>
-            <a:pPr>
-              <a:spcAft>
-                <a:spcPts val="800"/>
-              </a:spcAft>
-            </a:pPr>
-            <a:r>
-              <a:rPr sz="2000" b="0" i="0">
-                <a:solidFill>
-                  <a:srgbClr val="E8EDF2"/>
-                </a:solidFill>
-                <a:latin typeface="Arial"/>
-              </a:rPr>
-              <a:t>—   A method absent from the grant is simply refused</a:t>
-            </a:r>
-          </a:p>
-          <a:p>
-            <a:pPr>
-              <a:spcAft>
-                <a:spcPts val="800"/>
-              </a:spcAft>
-            </a:pPr>
-            <a:r>
-              <a:rPr sz="1800" b="0" i="0">
-                <a:solidFill>
-                  <a:srgbClr val="8A97A3"/>
-                </a:solidFill>
-                <a:latin typeface="Arial"/>
-              </a:rPr>
-              <a:t/>
-            </a:r>
-          </a:p>
-          <a:p>
-            <a:pPr>
-              <a:spcAft>
-                <a:spcPts val="800"/>
-              </a:spcAft>
-            </a:pPr>
-            <a:r>
-              <a:rPr sz="2000" b="1" i="0">
-                <a:solidFill>
-                  <a:srgbClr val="7FD8E8"/>
-                </a:solidFill>
-                <a:latin typeface="Arial"/>
-              </a:rPr>
-              <a:t>No bearer tokens to steal. No macaroon to copy.</a:t>
+              <a:t>—   The signer can run inside an attested secure enclave.</a:t>
             </a:r>
           </a:p>
         </p:txBody>

</xml_diff>

<commit_message>
Add the August 2026 incidents to the deck
The problem slide asserted that a node is a hot wallet with a web server
attached. This summer supplied the evidence, so the deck now shows it
rather than claiming it.

BTCPay Server: an unauthenticated request could read LND macaroon files,
actively exploited, merchant channels drained — and patching did not
invalidate the credentials already taken. Core Lightning: multiple
critical flaws, source withheld fourteen days, operators told to upgrade
or run offline. LND: a cooperative-close flaw risking a whole channel
balance.

Two of the three are the shape rather than the code — a credential that
can be stolen, and an interface that can be reached. That is the part
this architecture answers, and the deck says only that.
</commit_message>
<xml_diff>
--- a/doc/diamond-lightning-node.pptx
+++ b/doc/diamond-lightning-node.pptx
@@ -14,6 +14,7 @@
     <p:sldId id="262" r:id="rId13"/>
     <p:sldId id="263" r:id="rId14"/>
     <p:sldId id="264" r:id="rId15"/>
+    <p:sldId id="265" r:id="rId16"/>
   </p:sldIdLst>
   <p:sldSz cx="12191695" cy="6858000" type="screen4x3"/>
   <p:notesSz cx="6858000" cy="9144000"/>
@@ -3325,6 +3326,289 @@
 </p:sld>
 </file>
 
+<file path=ppt/slides/slide10.xml><?xml version="1.0" encoding="utf-8"?>
+<p:sld xmlns:a="http://schemas.openxmlformats.org/drawingml/2006/main" xmlns:p="http://schemas.openxmlformats.org/presentationml/2006/main" xmlns:r="http://schemas.openxmlformats.org/officeDocument/2006/relationships">
+  <p:cSld>
+    <p:spTree>
+      <p:nvGrpSpPr>
+        <p:cNvPr id="1" name=""/>
+        <p:cNvGrpSpPr/>
+        <p:nvPr/>
+      </p:nvGrpSpPr>
+      <p:grpSpPr/>
+      <p:sp>
+        <p:nvSpPr>
+          <p:cNvPr id="2" name="Rectangle 1"/>
+          <p:cNvSpPr/>
+          <p:nvPr/>
+        </p:nvSpPr>
+        <p:spPr>
+          <a:xfrm>
+            <a:off x="0" y="0"/>
+            <a:ext cx="12191695" cy="6858000"/>
+          </a:xfrm>
+          <a:prstGeom prst="rect">
+            <a:avLst/>
+          </a:prstGeom>
+          <a:solidFill>
+            <a:srgbClr val="0B0F14"/>
+          </a:solidFill>
+          <a:ln>
+            <a:noFill/>
+          </a:ln>
+          <a:effectLst/>
+        </p:spPr>
+        <p:style>
+          <a:lnRef idx="1">
+            <a:schemeClr val="accent1"/>
+          </a:lnRef>
+          <a:fillRef idx="3">
+            <a:schemeClr val="accent1"/>
+          </a:fillRef>
+          <a:effectRef idx="2">
+            <a:schemeClr val="accent1"/>
+          </a:effectRef>
+          <a:fontRef idx="minor">
+            <a:schemeClr val="lt1"/>
+          </a:fontRef>
+        </p:style>
+        <p:txBody>
+          <a:bodyPr rtlCol="0" anchor="ctr"/>
+          <a:lstStyle/>
+          <a:p>
+            <a:pPr algn="ctr"/>
+          </a:p>
+        </p:txBody>
+      </p:sp>
+      <p:sp>
+        <p:nvSpPr>
+          <p:cNvPr id="3" name="TextBox 2"/>
+          <p:cNvSpPr txBox="1"/>
+          <p:nvPr/>
+        </p:nvSpPr>
+        <p:spPr>
+          <a:xfrm>
+            <a:off x="822960" y="566928"/>
+            <a:ext cx="10058400" cy="365760"/>
+          </a:xfrm>
+          <a:prstGeom prst="rect">
+            <a:avLst/>
+          </a:prstGeom>
+          <a:noFill/>
+        </p:spPr>
+        <p:txBody>
+          <a:bodyPr wrap="square" lIns="0" rIns="0" tIns="0" bIns="0">
+            <a:spAutoFit/>
+          </a:bodyPr>
+          <a:lstStyle/>
+          <a:p>
+            <a:pPr>
+              <a:spcAft>
+                <a:spcPts val="0"/>
+              </a:spcAft>
+            </a:pPr>
+            <a:r>
+              <a:rPr sz="1200" b="1" i="0">
+                <a:solidFill>
+                  <a:srgbClr val="7FD8E8"/>
+                </a:solidFill>
+                <a:latin typeface="Arial"/>
+              </a:rPr>
+              <a:t>WHERE IT STANDS</a:t>
+            </a:r>
+          </a:p>
+        </p:txBody>
+      </p:sp>
+      <p:sp>
+        <p:nvSpPr>
+          <p:cNvPr id="4" name="TextBox 3"/>
+          <p:cNvSpPr txBox="1"/>
+          <p:nvPr/>
+        </p:nvSpPr>
+        <p:spPr>
+          <a:xfrm>
+            <a:off x="822960" y="1051560"/>
+            <a:ext cx="10515600" cy="1280160"/>
+          </a:xfrm>
+          <a:prstGeom prst="rect">
+            <a:avLst/>
+          </a:prstGeom>
+          <a:noFill/>
+        </p:spPr>
+        <p:txBody>
+          <a:bodyPr wrap="square" lIns="0" rIns="0" tIns="0" bIns="0">
+            <a:spAutoFit/>
+          </a:bodyPr>
+          <a:lstStyle/>
+          <a:p>
+            <a:pPr>
+              <a:spcAft>
+                <a:spcPts val="0"/>
+              </a:spcAft>
+            </a:pPr>
+            <a:r>
+              <a:rPr sz="3800" b="1" i="0">
+                <a:solidFill>
+                  <a:srgbClr val="E8EDF2"/>
+                </a:solidFill>
+                <a:latin typeface="Arial"/>
+              </a:rPr>
+              <a:t>Fast is demonstrated.
+Safe is not yet.</a:t>
+            </a:r>
+          </a:p>
+        </p:txBody>
+      </p:sp>
+      <p:sp>
+        <p:nvSpPr>
+          <p:cNvPr id="5" name="TextBox 4"/>
+          <p:cNvSpPr txBox="1"/>
+          <p:nvPr/>
+        </p:nvSpPr>
+        <p:spPr>
+          <a:xfrm>
+            <a:off x="822960" y="3017520"/>
+            <a:ext cx="10515600" cy="3840480"/>
+          </a:xfrm>
+          <a:prstGeom prst="rect">
+            <a:avLst/>
+          </a:prstGeom>
+          <a:noFill/>
+        </p:spPr>
+        <p:txBody>
+          <a:bodyPr wrap="square" lIns="0" rIns="0" tIns="0" bIns="0">
+            <a:spAutoFit/>
+          </a:bodyPr>
+          <a:lstStyle/>
+          <a:p>
+            <a:pPr>
+              <a:spcAft>
+                <a:spcPts val="1200"/>
+              </a:spcAft>
+            </a:pPr>
+            <a:r>
+              <a:rPr sz="2000" b="0" i="0">
+                <a:solidFill>
+                  <a:srgbClr val="E8EDF2"/>
+                </a:solidFill>
+                <a:latin typeface="Arial"/>
+              </a:rPr>
+              <a:t>—   Proven — the happy path, end to end, on both chains, across the fork</a:t>
+            </a:r>
+          </a:p>
+          <a:p>
+            <a:pPr>
+              <a:spcAft>
+                <a:spcPts val="1200"/>
+              </a:spcAft>
+            </a:pPr>
+            <a:r>
+              <a:rPr sz="2000" b="0" i="0">
+                <a:solidFill>
+                  <a:srgbClr val="E8EDF2"/>
+                </a:solidFill>
+                <a:latin typeface="Arial"/>
+              </a:rPr>
+              <a:t>—   Not proven — force closes, HTLC timeouts, on-chain claims</a:t>
+            </a:r>
+          </a:p>
+          <a:p>
+            <a:pPr>
+              <a:spcAft>
+                <a:spcPts val="1200"/>
+              </a:spcAft>
+            </a:pPr>
+            <a:r>
+              <a:rPr sz="1800" b="0" i="0">
+                <a:solidFill>
+                  <a:srgbClr val="8A97A3"/>
+                </a:solidFill>
+                <a:latin typeface="Arial"/>
+              </a:rPr>
+              <a:t/>
+            </a:r>
+          </a:p>
+          <a:p>
+            <a:pPr>
+              <a:spcAft>
+                <a:spcPts val="1200"/>
+              </a:spcAft>
+            </a:pPr>
+            <a:r>
+              <a:rPr sz="2000" b="0" i="0">
+                <a:solidFill>
+                  <a:srgbClr val="E8EDF2"/>
+                </a:solidFill>
+                <a:latin typeface="Arial"/>
+              </a:rPr>
+              <a:t>Every scenario so far ends with both parties cooperating. The safety</a:t>
+            </a:r>
+          </a:p>
+          <a:p>
+            <a:pPr>
+              <a:spcAft>
+                <a:spcPts val="1200"/>
+              </a:spcAft>
+            </a:pPr>
+            <a:r>
+              <a:rPr sz="2000" b="0" i="0">
+                <a:solidFill>
+                  <a:srgbClr val="E8EDF2"/>
+                </a:solidFill>
+                <a:latin typeface="Arial"/>
+              </a:rPr>
+              <a:t>argument rests entirely on what happens when one of them does not.</a:t>
+            </a:r>
+          </a:p>
+        </p:txBody>
+      </p:sp>
+      <p:sp>
+        <p:nvSpPr>
+          <p:cNvPr id="6" name="TextBox 5"/>
+          <p:cNvSpPr txBox="1"/>
+          <p:nvPr/>
+        </p:nvSpPr>
+        <p:spPr>
+          <a:xfrm>
+            <a:off x="822960" y="5989320"/>
+            <a:ext cx="10515600" cy="457200"/>
+          </a:xfrm>
+          <a:prstGeom prst="rect">
+            <a:avLst/>
+          </a:prstGeom>
+          <a:noFill/>
+        </p:spPr>
+        <p:txBody>
+          <a:bodyPr wrap="square" lIns="0" rIns="0" tIns="0" bIns="0">
+            <a:spAutoFit/>
+          </a:bodyPr>
+          <a:lstStyle/>
+          <a:p>
+            <a:pPr>
+              <a:spcAft>
+                <a:spcPts val="0"/>
+              </a:spcAft>
+            </a:pPr>
+            <a:r>
+              <a:rPr sz="1400" b="0" i="1">
+                <a:solidFill>
+                  <a:srgbClr val="8A97A3"/>
+                </a:solidFill>
+                <a:latin typeface="Arial"/>
+              </a:rPr>
+              <a:t>That is the next mission, and it is deliberately not claimed yet.</a:t>
+            </a:r>
+          </a:p>
+        </p:txBody>
+      </p:sp>
+    </p:spTree>
+  </p:cSld>
+  <p:clrMapOvr>
+    <a:masterClrMapping/>
+  </p:clrMapOvr>
+</p:sld>
+</file>
+
 <file path=ppt/slides/slide2.xml><?xml version="1.0" encoding="utf-8"?>
 <p:sld xmlns:a="http://schemas.openxmlformats.org/drawingml/2006/main" xmlns:p="http://schemas.openxmlformats.org/presentationml/2006/main" xmlns:r="http://schemas.openxmlformats.org/officeDocument/2006/relationships">
   <p:cSld>
@@ -3664,45 +3948,21 @@
                 </a:solidFill>
                 <a:latin typeface="Arial"/>
               </a:rPr>
-              <a:t>THE ARCHITECTURE</a:t>
-            </a:r>
-          </a:p>
-        </p:txBody>
-      </p:sp>
-      <p:pic>
-        <p:nvPicPr>
-          <p:cNvPr id="4" name="Picture 3" descr="design-dark.png"/>
-          <p:cNvPicPr>
-            <a:picLocks noChangeAspect="1"/>
-          </p:cNvPicPr>
-          <p:nvPr/>
-        </p:nvPicPr>
-        <p:blipFill>
-          <a:blip r:embed="rId2"/>
-          <a:stretch>
-            <a:fillRect/>
-          </a:stretch>
-        </p:blipFill>
-        <p:spPr>
-          <a:xfrm>
-            <a:off x="2599829" y="1024128"/>
-            <a:ext cx="6992037" cy="4892040"/>
-          </a:xfrm>
-          <a:prstGeom prst="rect">
-            <a:avLst/>
-          </a:prstGeom>
-        </p:spPr>
-      </p:pic>
-      <p:sp>
-        <p:nvSpPr>
-          <p:cNvPr id="5" name="TextBox 4"/>
+              <a:t>AUGUST 2026</a:t>
+            </a:r>
+          </a:p>
+        </p:txBody>
+      </p:sp>
+      <p:sp>
+        <p:nvSpPr>
+          <p:cNvPr id="4" name="TextBox 3"/>
           <p:cNvSpPr txBox="1"/>
           <p:nvPr/>
         </p:nvSpPr>
         <p:spPr>
           <a:xfrm>
-            <a:off x="822960" y="5989320"/>
-            <a:ext cx="10515600" cy="457200"/>
+            <a:off x="822960" y="1051560"/>
+            <a:ext cx="10515600" cy="1280160"/>
           </a:xfrm>
           <a:prstGeom prst="rect">
             <a:avLst/>
@@ -3721,13 +3981,251 @@
               </a:spcAft>
             </a:pPr>
             <a:r>
+              <a:rPr sz="3400" b="1" i="0">
+                <a:solidFill>
+                  <a:srgbClr val="E8EDF2"/>
+                </a:solidFill>
+                <a:latin typeface="Arial"/>
+              </a:rPr>
+              <a:t>A summer of operators afraid of their own nodes</a:t>
+            </a:r>
+          </a:p>
+        </p:txBody>
+      </p:sp>
+      <p:sp>
+        <p:nvSpPr>
+          <p:cNvPr id="5" name="TextBox 4"/>
+          <p:cNvSpPr txBox="1"/>
+          <p:nvPr/>
+        </p:nvSpPr>
+        <p:spPr>
+          <a:xfrm>
+            <a:off x="822960" y="2148840"/>
+            <a:ext cx="10515600" cy="3840480"/>
+          </a:xfrm>
+          <a:prstGeom prst="rect">
+            <a:avLst/>
+          </a:prstGeom>
+          <a:noFill/>
+        </p:spPr>
+        <p:txBody>
+          <a:bodyPr wrap="square" lIns="0" rIns="0" tIns="0" bIns="0">
+            <a:spAutoFit/>
+          </a:bodyPr>
+          <a:lstStyle/>
+          <a:p>
+            <a:pPr>
+              <a:spcAft>
+                <a:spcPts val="500"/>
+              </a:spcAft>
+            </a:pPr>
+            <a:r>
+              <a:rPr sz="1900" b="1" i="0">
+                <a:solidFill>
+                  <a:srgbClr val="7FD8E8"/>
+                </a:solidFill>
+                <a:latin typeface="Arial"/>
+              </a:rPr>
+              <a:t>BTCPay Server  ·  funds actually taken</a:t>
+            </a:r>
+          </a:p>
+          <a:p>
+            <a:pPr>
+              <a:spcAft>
+                <a:spcPts val="500"/>
+              </a:spcAft>
+            </a:pPr>
+            <a:r>
+              <a:rPr sz="1700" b="0" i="0">
+                <a:solidFill>
+                  <a:srgbClr val="8A97A3"/>
+                </a:solidFill>
+                <a:latin typeface="Arial"/>
+              </a:rPr>
+              <a:t>An unauthenticated request could read LND's .macaroon files. Actively</a:t>
+            </a:r>
+          </a:p>
+          <a:p>
+            <a:pPr>
+              <a:spcAft>
+                <a:spcPts val="500"/>
+              </a:spcAft>
+            </a:pPr>
+            <a:r>
+              <a:rPr sz="1700" b="0" i="0">
+                <a:solidFill>
+                  <a:srgbClr val="8A97A3"/>
+                </a:solidFill>
+                <a:latin typeface="Arial"/>
+              </a:rPr>
+              <a:t>exploited; merchant channels drained. Patching stopped new access — it</a:t>
+            </a:r>
+          </a:p>
+          <a:p>
+            <a:pPr>
+              <a:spcAft>
+                <a:spcPts val="500"/>
+              </a:spcAft>
+            </a:pPr>
+            <a:r>
+              <a:rPr sz="1700" b="0" i="0">
+                <a:solidFill>
+                  <a:srgbClr val="8A97A3"/>
+                </a:solidFill>
+                <a:latin typeface="Arial"/>
+              </a:rPr>
+              <a:t>did not invalidate the credentials already stolen.</a:t>
+            </a:r>
+          </a:p>
+          <a:p>
+            <a:pPr>
+              <a:spcAft>
+                <a:spcPts val="500"/>
+              </a:spcAft>
+            </a:pPr>
+            <a:r>
+              <a:rPr sz="1700" b="0" i="0">
+                <a:solidFill>
+                  <a:srgbClr val="8A97A3"/>
+                </a:solidFill>
+                <a:latin typeface="Arial"/>
+              </a:rPr>
+              <a:t/>
+            </a:r>
+          </a:p>
+          <a:p>
+            <a:pPr>
+              <a:spcAft>
+                <a:spcPts val="500"/>
+              </a:spcAft>
+            </a:pPr>
+            <a:r>
+              <a:rPr sz="1900" b="1" i="0">
+                <a:solidFill>
+                  <a:srgbClr val="7FD8E8"/>
+                </a:solidFill>
+                <a:latin typeface="Arial"/>
+              </a:rPr>
+              <a:t>Core Lightning  ·  told to go offline</a:t>
+            </a:r>
+          </a:p>
+          <a:p>
+            <a:pPr>
+              <a:spcAft>
+                <a:spcPts val="500"/>
+              </a:spcAft>
+            </a:pPr>
+            <a:r>
+              <a:rPr sz="1700" b="0" i="0">
+                <a:solidFill>
+                  <a:srgbClr val="8A97A3"/>
+                </a:solidFill>
+                <a:latin typeface="Arial"/>
+              </a:rPr>
+              <a:t>Multiple critical flaws, source withheld 14 days so they could not be</a:t>
+            </a:r>
+          </a:p>
+          <a:p>
+            <a:pPr>
+              <a:spcAft>
+                <a:spcPts val="500"/>
+              </a:spcAft>
+            </a:pPr>
+            <a:r>
+              <a:rPr sz="1700" b="0" i="0">
+                <a:solidFill>
+                  <a:srgbClr val="8A97A3"/>
+                </a:solidFill>
+                <a:latin typeface="Arial"/>
+              </a:rPr>
+              <a:t>reverse-engineered. Upgrade, or restart with --offline.</a:t>
+            </a:r>
+          </a:p>
+          <a:p>
+            <a:pPr>
+              <a:spcAft>
+                <a:spcPts val="500"/>
+              </a:spcAft>
+            </a:pPr>
+            <a:r>
+              <a:rPr sz="1700" b="0" i="0">
+                <a:solidFill>
+                  <a:srgbClr val="8A97A3"/>
+                </a:solidFill>
+                <a:latin typeface="Arial"/>
+              </a:rPr>
+              <a:t/>
+            </a:r>
+          </a:p>
+          <a:p>
+            <a:pPr>
+              <a:spcAft>
+                <a:spcPts val="500"/>
+              </a:spcAft>
+            </a:pPr>
+            <a:r>
+              <a:rPr sz="1900" b="1" i="0">
+                <a:solidFill>
+                  <a:srgbClr val="7FD8E8"/>
+                </a:solidFill>
+                <a:latin typeface="Arial"/>
+              </a:rPr>
+              <a:t>LND  ·  cooperative close</a:t>
+            </a:r>
+          </a:p>
+          <a:p>
+            <a:pPr>
+              <a:spcAft>
+                <a:spcPts val="500"/>
+              </a:spcAft>
+            </a:pPr>
+            <a:r>
+              <a:rPr sz="1700" b="0" i="0">
+                <a:solidFill>
+                  <a:srgbClr val="8A97A3"/>
+                </a:solidFill>
+                <a:latin typeface="Arial"/>
+              </a:rPr>
+              <a:t>A channel-close flaw putting an entire channel balance at risk.</a:t>
+            </a:r>
+          </a:p>
+        </p:txBody>
+      </p:sp>
+      <p:sp>
+        <p:nvSpPr>
+          <p:cNvPr id="6" name="TextBox 5"/>
+          <p:cNvSpPr txBox="1"/>
+          <p:nvPr/>
+        </p:nvSpPr>
+        <p:spPr>
+          <a:xfrm>
+            <a:off x="822960" y="5989320"/>
+            <a:ext cx="10515600" cy="457200"/>
+          </a:xfrm>
+          <a:prstGeom prst="rect">
+            <a:avLst/>
+          </a:prstGeom>
+          <a:noFill/>
+        </p:spPr>
+        <p:txBody>
+          <a:bodyPr wrap="square" lIns="0" rIns="0" tIns="0" bIns="0">
+            <a:spAutoFit/>
+          </a:bodyPr>
+          <a:lstStyle/>
+          <a:p>
+            <a:pPr>
+              <a:spcAft>
+                <a:spcPts val="0"/>
+              </a:spcAft>
+            </a:pPr>
+            <a:r>
               <a:rPr sz="1400" b="0" i="1">
                 <a:solidFill>
                   <a:srgbClr val="8A97A3"/>
                 </a:solidFill>
                 <a:latin typeface="Arial"/>
               </a:rPr>
-              <a:t>Three roles, three protocols, and a signer the node cannot talk past.</a:t>
+              <a:t>Two of these are the shape, not the code: a credential that can be stolen, and an interface that can be reached.</a:t>
             </a:r>
           </a:p>
         </p:txBody>
@@ -3828,21 +4326,45 @@
                 </a:solidFill>
                 <a:latin typeface="Arial"/>
               </a:rPr>
-              <a:t>SEPARATION OF POWERS</a:t>
-            </a:r>
-          </a:p>
-        </p:txBody>
-      </p:sp>
-      <p:sp>
-        <p:nvSpPr>
-          <p:cNvPr id="4" name="TextBox 3"/>
+              <a:t>THE ARCHITECTURE</a:t>
+            </a:r>
+          </a:p>
+        </p:txBody>
+      </p:sp>
+      <p:pic>
+        <p:nvPicPr>
+          <p:cNvPr id="4" name="Picture 3" descr="design-dark.png"/>
+          <p:cNvPicPr>
+            <a:picLocks noChangeAspect="1"/>
+          </p:cNvPicPr>
+          <p:nvPr/>
+        </p:nvPicPr>
+        <p:blipFill>
+          <a:blip r:embed="rId2"/>
+          <a:stretch>
+            <a:fillRect/>
+          </a:stretch>
+        </p:blipFill>
+        <p:spPr>
+          <a:xfrm>
+            <a:off x="2599829" y="1024128"/>
+            <a:ext cx="6992037" cy="4892040"/>
+          </a:xfrm>
+          <a:prstGeom prst="rect">
+            <a:avLst/>
+          </a:prstGeom>
+        </p:spPr>
+      </p:pic>
+      <p:sp>
+        <p:nvSpPr>
+          <p:cNvPr id="5" name="TextBox 4"/>
           <p:cNvSpPr txBox="1"/>
           <p:nvPr/>
         </p:nvSpPr>
         <p:spPr>
           <a:xfrm>
-            <a:off x="822960" y="1051560"/>
-            <a:ext cx="10515600" cy="1280160"/>
+            <a:off x="822960" y="5989320"/>
+            <a:ext cx="10515600" cy="457200"/>
           </a:xfrm>
           <a:prstGeom prst="rect">
             <a:avLst/>
@@ -3861,171 +4383,13 @@
               </a:spcAft>
             </a:pPr>
             <a:r>
-              <a:rPr sz="4000" b="1" i="0">
-                <a:solidFill>
-                  <a:srgbClr val="E8EDF2"/>
-                </a:solidFill>
-                <a:latin typeface="Arial"/>
-              </a:rPr>
-              <a:t>Three roles, and none of them is trusted twice</a:t>
-            </a:r>
-          </a:p>
-        </p:txBody>
-      </p:sp>
-      <p:sp>
-        <p:nvSpPr>
-          <p:cNvPr id="5" name="TextBox 4"/>
-          <p:cNvSpPr txBox="1"/>
-          <p:nvPr/>
-        </p:nvSpPr>
-        <p:spPr>
-          <a:xfrm>
-            <a:off x="822960" y="2286000"/>
-            <a:ext cx="10515600" cy="3840480"/>
-          </a:xfrm>
-          <a:prstGeom prst="rect">
-            <a:avLst/>
-          </a:prstGeom>
-          <a:noFill/>
-        </p:spPr>
-        <p:txBody>
-          <a:bodyPr wrap="square" lIns="0" rIns="0" tIns="0" bIns="0">
-            <a:spAutoFit/>
-          </a:bodyPr>
-          <a:lstStyle/>
-          <a:p>
-            <a:pPr>
-              <a:spcAft>
-                <a:spcPts val="600"/>
-              </a:spcAft>
-            </a:pPr>
-            <a:r>
-              <a:rPr sz="2000" b="1" i="0">
-                <a:solidFill>
-                  <a:srgbClr val="7FD8E8"/>
-                </a:solidFill>
-                <a:latin typeface="Arial"/>
-              </a:rPr>
-              <a:t>Owner</a:t>
-            </a:r>
-          </a:p>
-          <a:p>
-            <a:pPr>
-              <a:spcAft>
-                <a:spcPts val="600"/>
-              </a:spcAft>
-            </a:pPr>
-            <a:r>
-              <a:rPr sz="1800" b="0" i="0">
+              <a:rPr sz="1400" b="0" i="1">
                 <a:solidFill>
                   <a:srgbClr val="8A97A3"/>
                 </a:solidFill>
                 <a:latin typeface="Arial"/>
               </a:rPr>
-              <a:t>Defines the signing policy. Touches nothing day to day.</a:t>
-            </a:r>
-          </a:p>
-          <a:p>
-            <a:pPr>
-              <a:spcAft>
-                <a:spcPts val="600"/>
-              </a:spcAft>
-            </a:pPr>
-            <a:r>
-              <a:rPr sz="2000" b="1" i="0">
-                <a:solidFill>
-                  <a:srgbClr val="7FD8E8"/>
-                </a:solidFill>
-                <a:latin typeface="Arial"/>
-              </a:rPr>
-              <a:t>User</a:t>
-            </a:r>
-          </a:p>
-          <a:p>
-            <a:pPr>
-              <a:spcAft>
-                <a:spcPts val="600"/>
-              </a:spcAft>
-            </a:pPr>
-            <a:r>
-              <a:rPr sz="1800" b="0" i="0">
-                <a:solidFill>
-                  <a:srgbClr val="8A97A3"/>
-                </a:solidFill>
-                <a:latin typeface="Arial"/>
-              </a:rPr>
-              <a:t>Spends through the wallet, within the Owner's permissions and limits.</a:t>
-            </a:r>
-          </a:p>
-          <a:p>
-            <a:pPr>
-              <a:spcAft>
-                <a:spcPts val="600"/>
-              </a:spcAft>
-            </a:pPr>
-            <a:r>
-              <a:rPr sz="2000" b="1" i="0">
-                <a:solidFill>
-                  <a:srgbClr val="7FD8E8"/>
-                </a:solidFill>
-                <a:latin typeface="Arial"/>
-              </a:rPr>
-              <a:t>Controller</a:t>
-            </a:r>
-          </a:p>
-          <a:p>
-            <a:pPr>
-              <a:spcAft>
-                <a:spcPts val="600"/>
-              </a:spcAft>
-            </a:pPr>
-            <a:r>
-              <a:rPr sz="1800" b="0" i="0">
-                <a:solidFill>
-                  <a:srgbClr val="8A97A3"/>
-                </a:solidFill>
-                <a:latin typeface="Arial"/>
-              </a:rPr>
-              <a:t>Operates the node — channels, peers, fees — under the same policy.</a:t>
-            </a:r>
-          </a:p>
-        </p:txBody>
-      </p:sp>
-      <p:sp>
-        <p:nvSpPr>
-          <p:cNvPr id="6" name="TextBox 5"/>
-          <p:cNvSpPr txBox="1"/>
-          <p:nvPr/>
-        </p:nvSpPr>
-        <p:spPr>
-          <a:xfrm>
-            <a:off x="822960" y="5989320"/>
-            <a:ext cx="10515600" cy="457200"/>
-          </a:xfrm>
-          <a:prstGeom prst="rect">
-            <a:avLst/>
-          </a:prstGeom>
-          <a:noFill/>
-        </p:spPr>
-        <p:txBody>
-          <a:bodyPr wrap="square" lIns="0" rIns="0" tIns="0" bIns="0">
-            <a:spAutoFit/>
-          </a:bodyPr>
-          <a:lstStyle/>
-          <a:p>
-            <a:pPr>
-              <a:spcAft>
-                <a:spcPts val="0"/>
-              </a:spcAft>
-            </a:pPr>
-            <a:r>
-              <a:rPr sz="1400" b="0" i="1">
-                <a:solidFill>
-                  <a:srgbClr val="8A97A3"/>
-                </a:solidFill>
-                <a:latin typeface="Arial"/>
-              </a:rPr>
-              <a:t>A role is a key, not an account. Capabilities are granted per key and per method.</a:t>
+              <a:t>Three roles, three protocols, and a signer the node cannot talk past.</a:t>
             </a:r>
           </a:p>
         </p:txBody>
@@ -4126,7 +4490,7 @@
                 </a:solidFill>
                 <a:latin typeface="Arial"/>
               </a:rPr>
-              <a:t>ONE TRANSPORT, THREE PROTOCOLS</a:t>
+              <a:t>SEPARATION OF POWERS</a:t>
             </a:r>
           </a:p>
         </p:txBody>
@@ -4165,7 +4529,7 @@
                 </a:solidFill>
                 <a:latin typeface="Arial"/>
               </a:rPr>
-              <a:t>Nostr is the only control plane</a:t>
+              <a:t>Three roles, and none of them is trusted twice</a:t>
             </a:r>
           </a:p>
         </p:txBody>
@@ -4178,7 +4542,7 @@
         </p:nvSpPr>
         <p:spPr>
           <a:xfrm>
-            <a:off x="822960" y="2240280"/>
+            <a:off x="822960" y="2286000"/>
             <a:ext cx="10515600" cy="3840480"/>
           </a:xfrm>
           <a:prstGeom prst="rect">
@@ -4204,7 +4568,7 @@
                 </a:solidFill>
                 <a:latin typeface="Arial"/>
               </a:rPr>
-              <a:t>NWC   ·   the wallet</a:t>
+              <a:t>Owner</a:t>
             </a:r>
           </a:p>
           <a:p>
@@ -4220,7 +4584,7 @@
                 </a:solidFill>
                 <a:latin typeface="Arial"/>
               </a:rPr>
-              <a:t>Invoices, payments, offers, on-chain. Extends NIP-47.</a:t>
+              <a:t>Defines the signing policy. Touches nothing day to day.</a:t>
             </a:r>
           </a:p>
           <a:p>
@@ -4236,7 +4600,7 @@
                 </a:solidFill>
                 <a:latin typeface="Arial"/>
               </a:rPr>
-              <a:t>NCC   ·   the node</a:t>
+              <a:t>User</a:t>
             </a:r>
           </a:p>
           <a:p>
@@ -4252,7 +4616,7 @@
                 </a:solidFill>
                 <a:latin typeface="Arial"/>
               </a:rPr>
-              <a:t>Channels, peers, fees, routing, network queries.</a:t>
+              <a:t>Spends through the wallet, within the Owner's permissions and limits.</a:t>
             </a:r>
           </a:p>
           <a:p>
@@ -4268,7 +4632,7 @@
                 </a:solidFill>
                 <a:latin typeface="Arial"/>
               </a:rPr>
-              <a:t>NSC   ·   the signer</a:t>
+              <a:t>Controller</a:t>
             </a:r>
           </a:p>
           <a:p>
@@ -4284,7 +4648,7 @@
                 </a:solidFill>
                 <a:latin typeface="Arial"/>
               </a:rPr>
-              <a:t>Signing requests, and the policy that governs them.</a:t>
+              <a:t>Operates the node — channels, peers, fees — under the same policy.</a:t>
             </a:r>
           </a:p>
         </p:txBody>
@@ -4323,7 +4687,7 @@
                 </a:solidFill>
                 <a:latin typeface="Arial"/>
               </a:rPr>
-              <a:t>No CLI. No local socket. Nothing listens for control — the node reaches out to a relay.</a:t>
+              <a:t>A role is a key, not an account. Capabilities are granted per key and per method.</a:t>
             </a:r>
           </a:p>
         </p:txBody>
@@ -4424,7 +4788,7 @@
                 </a:solidFill>
                 <a:latin typeface="Arial"/>
               </a:rPr>
-              <a:t>WHY THE SHAPE MATTERS</a:t>
+              <a:t>ONE TRANSPORT, THREE PROTOCOLS</a:t>
             </a:r>
           </a:p>
         </p:txBody>
@@ -4457,14 +4821,13 @@
               </a:spcAft>
             </a:pPr>
             <a:r>
-              <a:rPr sz="3800" b="1" i="0">
+              <a:rPr sz="4000" b="1" i="0">
                 <a:solidFill>
                   <a:srgbClr val="E8EDF2"/>
                 </a:solidFill>
                 <a:latin typeface="Arial"/>
               </a:rPr>
-              <a:t>Policy lives in the signer,
-not in the node</a:t>
+              <a:t>Nostr is the only control plane</a:t>
             </a:r>
           </a:p>
         </p:txBody>
@@ -4477,7 +4840,7 @@
         </p:nvSpPr>
         <p:spPr>
           <a:xfrm>
-            <a:off x="822960" y="2834640"/>
+            <a:off x="822960" y="2240280"/>
             <a:ext cx="10515600" cy="3840480"/>
           </a:xfrm>
           <a:prstGeom prst="rect">
@@ -4493,39 +4856,23 @@
           <a:p>
             <a:pPr>
               <a:spcAft>
-                <a:spcPts val="800"/>
-              </a:spcAft>
-            </a:pPr>
-            <a:r>
-              <a:rPr sz="2000" b="0" i="0">
-                <a:solidFill>
-                  <a:srgbClr val="E8EDF2"/>
-                </a:solidFill>
-                <a:latin typeface="Arial"/>
-              </a:rPr>
-              <a:t>The keys are not the node's. Every signature is a request the signer</a:t>
-            </a:r>
-          </a:p>
-          <a:p>
-            <a:pPr>
-              <a:spcAft>
-                <a:spcPts val="800"/>
-              </a:spcAft>
-            </a:pPr>
-            <a:r>
-              <a:rPr sz="2000" b="0" i="0">
-                <a:solidFill>
-                  <a:srgbClr val="E8EDF2"/>
-                </a:solidFill>
-                <a:latin typeface="Arial"/>
-              </a:rPr>
-              <a:t>validates against the Owner's policy — and can refuse.</a:t>
-            </a:r>
-          </a:p>
-          <a:p>
-            <a:pPr>
-              <a:spcAft>
-                <a:spcPts val="800"/>
+                <a:spcPts val="600"/>
+              </a:spcAft>
+            </a:pPr>
+            <a:r>
+              <a:rPr sz="2000" b="1" i="0">
+                <a:solidFill>
+                  <a:srgbClr val="7FD8E8"/>
+                </a:solidFill>
+                <a:latin typeface="Arial"/>
+              </a:rPr>
+              <a:t>NWC   ·   the wallet</a:t>
+            </a:r>
+          </a:p>
+          <a:p>
+            <a:pPr>
+              <a:spcAft>
+                <a:spcPts val="600"/>
               </a:spcAft>
             </a:pPr>
             <a:r>
@@ -4535,13 +4882,13 @@
                 </a:solidFill>
                 <a:latin typeface="Arial"/>
               </a:rPr>
-              <a:t/>
-            </a:r>
-          </a:p>
-          <a:p>
-            <a:pPr>
-              <a:spcAft>
-                <a:spcPts val="800"/>
+              <a:t>Invoices, payments, offers, on-chain. Extends NIP-47.</a:t>
+            </a:r>
+          </a:p>
+          <a:p>
+            <a:pPr>
+              <a:spcAft>
+                <a:spcPts val="600"/>
               </a:spcAft>
             </a:pPr>
             <a:r>
@@ -4551,13 +4898,29 @@
                 </a:solidFill>
                 <a:latin typeface="Arial"/>
               </a:rPr>
-              <a:t>A user or controller cannot make the signer approve an operation</a:t>
-            </a:r>
-          </a:p>
-          <a:p>
-            <a:pPr>
-              <a:spcAft>
-                <a:spcPts val="800"/>
+              <a:t>NCC   ·   the node</a:t>
+            </a:r>
+          </a:p>
+          <a:p>
+            <a:pPr>
+              <a:spcAft>
+                <a:spcPts val="600"/>
+              </a:spcAft>
+            </a:pPr>
+            <a:r>
+              <a:rPr sz="1800" b="0" i="0">
+                <a:solidFill>
+                  <a:srgbClr val="8A97A3"/>
+                </a:solidFill>
+                <a:latin typeface="Arial"/>
+              </a:rPr>
+              <a:t>Channels, peers, fees, routing, network queries.</a:t>
+            </a:r>
+          </a:p>
+          <a:p>
+            <a:pPr>
+              <a:spcAft>
+                <a:spcPts val="600"/>
               </a:spcAft>
             </a:pPr>
             <a:r>
@@ -4567,13 +4930,13 @@
                 </a:solidFill>
                 <a:latin typeface="Arial"/>
               </a:rPr>
-              <a:t>outside that policy merely by controlling dln-node.</a:t>
-            </a:r>
-          </a:p>
-          <a:p>
-            <a:pPr>
-              <a:spcAft>
-                <a:spcPts val="800"/>
+              <a:t>NSC   ·   the signer</a:t>
+            </a:r>
+          </a:p>
+          <a:p>
+            <a:pPr>
+              <a:spcAft>
+                <a:spcPts val="600"/>
               </a:spcAft>
             </a:pPr>
             <a:r>
@@ -4583,23 +4946,46 @@
                 </a:solidFill>
                 <a:latin typeface="Arial"/>
               </a:rPr>
-              <a:t/>
-            </a:r>
-          </a:p>
-          <a:p>
-            <a:pPr>
-              <a:spcAft>
-                <a:spcPts val="800"/>
-              </a:spcAft>
-            </a:pPr>
-            <a:r>
-              <a:rPr sz="2000" b="0" i="0">
-                <a:solidFill>
-                  <a:srgbClr val="E8EDF2"/>
-                </a:solidFill>
-                <a:latin typeface="Arial"/>
-              </a:rPr>
-              <a:t>—   The signer can run inside an attested secure enclave.</a:t>
+              <a:t>Signing requests, and the policy that governs them.</a:t>
+            </a:r>
+          </a:p>
+        </p:txBody>
+      </p:sp>
+      <p:sp>
+        <p:nvSpPr>
+          <p:cNvPr id="6" name="TextBox 5"/>
+          <p:cNvSpPr txBox="1"/>
+          <p:nvPr/>
+        </p:nvSpPr>
+        <p:spPr>
+          <a:xfrm>
+            <a:off x="822960" y="5989320"/>
+            <a:ext cx="10515600" cy="457200"/>
+          </a:xfrm>
+          <a:prstGeom prst="rect">
+            <a:avLst/>
+          </a:prstGeom>
+          <a:noFill/>
+        </p:spPr>
+        <p:txBody>
+          <a:bodyPr wrap="square" lIns="0" rIns="0" tIns="0" bIns="0">
+            <a:spAutoFit/>
+          </a:bodyPr>
+          <a:lstStyle/>
+          <a:p>
+            <a:pPr>
+              <a:spcAft>
+                <a:spcPts val="0"/>
+              </a:spcAft>
+            </a:pPr>
+            <a:r>
+              <a:rPr sz="1400" b="0" i="1">
+                <a:solidFill>
+                  <a:srgbClr val="8A97A3"/>
+                </a:solidFill>
+                <a:latin typeface="Arial"/>
+              </a:rPr>
+              <a:t>No CLI. No local socket. Nothing listens for control — the node reaches out to a relay.</a:t>
             </a:r>
           </a:p>
         </p:txBody>
@@ -4700,7 +5086,7 @@
                 </a:solidFill>
                 <a:latin typeface="Arial"/>
               </a:rPr>
-              <a:t>WHAT IT UNLOCKS</a:t>
+              <a:t>WHY THE SHAPE MATTERS</a:t>
             </a:r>
           </a:p>
         </p:txBody>
@@ -4733,13 +5119,14 @@
               </a:spcAft>
             </a:pPr>
             <a:r>
-              <a:rPr sz="4000" b="1" i="0">
+              <a:rPr sz="3800" b="1" i="0">
                 <a:solidFill>
                   <a:srgbClr val="E8EDF2"/>
                 </a:solidFill>
                 <a:latin typeface="Arial"/>
               </a:rPr>
-              <a:t>diamond-x — swapping BTC against BTK</a:t>
+              <a:t>Policy lives in the signer,
+not in the node</a:t>
             </a:r>
           </a:p>
         </p:txBody>
@@ -4752,7 +5139,7 @@
         </p:nvSpPr>
         <p:spPr>
           <a:xfrm>
-            <a:off x="822960" y="2286000"/>
+            <a:off x="822960" y="2834640"/>
             <a:ext cx="10515600" cy="3840480"/>
           </a:xfrm>
           <a:prstGeom prst="rect">
@@ -4768,7 +5155,7 @@
           <a:p>
             <a:pPr>
               <a:spcAft>
-                <a:spcPts val="1200"/>
+                <a:spcPts val="800"/>
               </a:spcAft>
             </a:pPr>
             <a:r>
@@ -4778,13 +5165,13 @@
                 </a:solidFill>
                 <a:latin typeface="Arial"/>
               </a:rPr>
-              <a:t>Two chains, two channels, one payment hash.</a:t>
-            </a:r>
-          </a:p>
-          <a:p>
-            <a:pPr>
-              <a:spcAft>
-                <a:spcPts val="1200"/>
+              <a:t>The keys are not the node's. Every signature is a request the signer</a:t>
+            </a:r>
+          </a:p>
+          <a:p>
+            <a:pPr>
+              <a:spcAft>
+                <a:spcPts val="800"/>
               </a:spcAft>
             </a:pPr>
             <a:r>
@@ -4794,13 +5181,13 @@
                 </a:solidFill>
                 <a:latin typeface="Arial"/>
               </a:rPr>
-              <a:t>Neither side can take their leg without enabling the other.</a:t>
-            </a:r>
-          </a:p>
-          <a:p>
-            <a:pPr>
-              <a:spcAft>
-                <a:spcPts val="1200"/>
+              <a:t>validates against the Owner's policy — and can refuse.</a:t>
+            </a:r>
+          </a:p>
+          <a:p>
+            <a:pPr>
+              <a:spcAft>
+                <a:spcPts val="800"/>
               </a:spcAft>
             </a:pPr>
             <a:r>
@@ -4816,7 +5203,55 @@
           <a:p>
             <a:pPr>
               <a:spcAft>
-                <a:spcPts val="1200"/>
+                <a:spcPts val="800"/>
+              </a:spcAft>
+            </a:pPr>
+            <a:r>
+              <a:rPr sz="2000" b="1" i="0">
+                <a:solidFill>
+                  <a:srgbClr val="7FD8E8"/>
+                </a:solidFill>
+                <a:latin typeface="Arial"/>
+              </a:rPr>
+              <a:t>A user or controller cannot make the signer approve an operation</a:t>
+            </a:r>
+          </a:p>
+          <a:p>
+            <a:pPr>
+              <a:spcAft>
+                <a:spcPts val="800"/>
+              </a:spcAft>
+            </a:pPr>
+            <a:r>
+              <a:rPr sz="2000" b="1" i="0">
+                <a:solidFill>
+                  <a:srgbClr val="7FD8E8"/>
+                </a:solidFill>
+                <a:latin typeface="Arial"/>
+              </a:rPr>
+              <a:t>outside that policy merely by controlling dln-node.</a:t>
+            </a:r>
+          </a:p>
+          <a:p>
+            <a:pPr>
+              <a:spcAft>
+                <a:spcPts val="800"/>
+              </a:spcAft>
+            </a:pPr>
+            <a:r>
+              <a:rPr sz="1800" b="0" i="0">
+                <a:solidFill>
+                  <a:srgbClr val="8A97A3"/>
+                </a:solidFill>
+                <a:latin typeface="Arial"/>
+              </a:rPr>
+              <a:t/>
+            </a:r>
+          </a:p>
+          <a:p>
+            <a:pPr>
+              <a:spcAft>
+                <a:spcPts val="800"/>
               </a:spcAft>
             </a:pPr>
             <a:r>
@@ -4826,101 +5261,7 @@
                 </a:solidFill>
                 <a:latin typeface="Arial"/>
               </a:rPr>
-              <a:t>—   Hold invoices are the primitive that makes it atomic</a:t>
-            </a:r>
-          </a:p>
-          <a:p>
-            <a:pPr>
-              <a:spcAft>
-                <a:spcPts val="1200"/>
-              </a:spcAft>
-            </a:pPr>
-            <a:r>
-              <a:rPr sz="2000" b="0" i="0">
-                <a:solidFill>
-                  <a:srgbClr val="E8EDF2"/>
-                </a:solidFill>
-                <a:latin typeface="Arial"/>
-              </a:rPr>
-              <a:t>—   No custody: the exchange relays two parallel legs, holding nothing</a:t>
-            </a:r>
-          </a:p>
-        </p:txBody>
-      </p:sp>
-      <p:sp>
-        <p:nvSpPr>
-          <p:cNvPr id="6" name="TextBox 5"/>
-          <p:cNvSpPr txBox="1"/>
-          <p:nvPr/>
-        </p:nvSpPr>
-        <p:spPr>
-          <a:xfrm>
-            <a:off x="822960" y="4709160"/>
-            <a:ext cx="10515600" cy="1097280"/>
-          </a:xfrm>
-          <a:prstGeom prst="rect">
-            <a:avLst/>
-          </a:prstGeom>
-          <a:noFill/>
-        </p:spPr>
-        <p:txBody>
-          <a:bodyPr wrap="square" lIns="0" rIns="0" tIns="0" bIns="0">
-            <a:spAutoFit/>
-          </a:bodyPr>
-          <a:lstStyle/>
-          <a:p>
-            <a:pPr>
-              <a:spcAft>
-                <a:spcPts val="0"/>
-              </a:spcAft>
-            </a:pPr>
-            <a:r>
-              <a:rPr sz="4400" b="1" i="0">
-                <a:solidFill>
-                  <a:srgbClr val="7FD8E8"/>
-                </a:solidFill>
-                <a:latin typeface="Arial"/>
-              </a:rPr>
-              <a:t>3.7 seconds</a:t>
-            </a:r>
-          </a:p>
-        </p:txBody>
-      </p:sp>
-      <p:sp>
-        <p:nvSpPr>
-          <p:cNvPr id="7" name="TextBox 6"/>
-          <p:cNvSpPr txBox="1"/>
-          <p:nvPr/>
-        </p:nvSpPr>
-        <p:spPr>
-          <a:xfrm>
-            <a:off x="822960" y="5989320"/>
-            <a:ext cx="10515600" cy="457200"/>
-          </a:xfrm>
-          <a:prstGeom prst="rect">
-            <a:avLst/>
-          </a:prstGeom>
-          <a:noFill/>
-        </p:spPr>
-        <p:txBody>
-          <a:bodyPr wrap="square" lIns="0" rIns="0" tIns="0" bIns="0">
-            <a:spAutoFit/>
-          </a:bodyPr>
-          <a:lstStyle/>
-          <a:p>
-            <a:pPr>
-              <a:spcAft>
-                <a:spcPts val="0"/>
-              </a:spcAft>
-            </a:pPr>
-            <a:r>
-              <a:rPr sz="1400" b="0" i="1">
-                <a:solidFill>
-                  <a:srgbClr val="8A97A3"/>
-                </a:solidFill>
-                <a:latin typeface="Arial"/>
-              </a:rPr>
-              <a:t>Measured end to end, on regtest — not projected.</a:t>
+              <a:t>—   The signer can run inside an attested secure enclave.</a:t>
             </a:r>
           </a:p>
         </p:txBody>
@@ -5021,7 +5362,7 @@
                 </a:solidFill>
                 <a:latin typeface="Arial"/>
               </a:rPr>
-              <a:t>PROVEN WHERE IT IS HARDEST</a:t>
+              <a:t>WHAT IT UNLOCKS</a:t>
             </a:r>
           </a:p>
         </p:txBody>
@@ -5060,7 +5401,7 @@
                 </a:solidFill>
                 <a:latin typeface="Arial"/>
               </a:rPr>
-              <a:t>Across a consensus fork, live</a:t>
+              <a:t>diamond-x — swapping BTC against BTK</a:t>
             </a:r>
           </a:p>
         </p:txBody>
@@ -5073,7 +5414,7 @@
         </p:nvSpPr>
         <p:spPr>
           <a:xfrm>
-            <a:off x="822960" y="2240280"/>
+            <a:off x="822960" y="2286000"/>
             <a:ext cx="10515600" cy="3840480"/>
           </a:xfrm>
           <a:prstGeom prst="rect">
@@ -5089,7 +5430,39 @@
           <a:p>
             <a:pPr>
               <a:spcAft>
-                <a:spcPts val="1100"/>
+                <a:spcPts val="1200"/>
+              </a:spcAft>
+            </a:pPr>
+            <a:r>
+              <a:rPr sz="2000" b="0" i="0">
+                <a:solidFill>
+                  <a:srgbClr val="E8EDF2"/>
+                </a:solidFill>
+                <a:latin typeface="Arial"/>
+              </a:rPr>
+              <a:t>Two chains, two channels, one payment hash.</a:t>
+            </a:r>
+          </a:p>
+          <a:p>
+            <a:pPr>
+              <a:spcAft>
+                <a:spcPts val="1200"/>
+              </a:spcAft>
+            </a:pPr>
+            <a:r>
+              <a:rPr sz="2000" b="0" i="0">
+                <a:solidFill>
+                  <a:srgbClr val="E8EDF2"/>
+                </a:solidFill>
+                <a:latin typeface="Arial"/>
+              </a:rPr>
+              <a:t>Neither side can take their leg without enabling the other.</a:t>
+            </a:r>
+          </a:p>
+          <a:p>
+            <a:pPr>
+              <a:spcAft>
+                <a:spcPts val="1200"/>
               </a:spcAft>
             </a:pPr>
             <a:r>
@@ -5099,29 +5472,13 @@
                 </a:solidFill>
                 <a:latin typeface="Arial"/>
               </a:rPr>
-              <a:t>Bitcoin Knots changes the block header: 80 bytes to 164, and a new proof of work.</a:t>
-            </a:r>
-          </a:p>
-          <a:p>
-            <a:pPr>
-              <a:spcAft>
-                <a:spcPts val="1100"/>
-              </a:spcAft>
-            </a:pPr>
-            <a:r>
-              <a:rPr sz="1800" b="0" i="0">
-                <a:solidFill>
-                  <a:srgbClr val="8A97A3"/>
-                </a:solidFill>
-                <a:latin typeface="Arial"/>
-              </a:rPr>
               <a:t/>
             </a:r>
           </a:p>
           <a:p>
             <a:pPr>
               <a:spcAft>
-                <a:spcPts val="1100"/>
+                <a:spcPts val="1200"/>
               </a:spcAft>
             </a:pPr>
             <a:r>
@@ -5131,13 +5488,13 @@
                 </a:solidFill>
                 <a:latin typeface="Arial"/>
               </a:rPr>
-              <a:t>—   v2 header support through the whole Rust stack</a:t>
-            </a:r>
-          </a:p>
-          <a:p>
-            <a:pPr>
-              <a:spcAft>
-                <a:spcPts val="1100"/>
+              <a:t>—   Hold invoices are the primitive that makes it atomic</a:t>
+            </a:r>
+          </a:p>
+          <a:p>
+            <a:pPr>
+              <a:spcAft>
+                <a:spcPts val="1200"/>
               </a:spcAft>
             </a:pPr>
             <a:r>
@@ -5147,39 +5504,7 @@
                 </a:solidFill>
                 <a:latin typeface="Arial"/>
               </a:rPr>
-              <a:t>—   A node follows the chain across activation without losing a channel</a:t>
-            </a:r>
-          </a:p>
-          <a:p>
-            <a:pPr>
-              <a:spcAft>
-                <a:spcPts val="1100"/>
-              </a:spcAft>
-            </a:pPr>
-            <a:r>
-              <a:rPr sz="2000" b="0" i="0">
-                <a:solidFill>
-                  <a:srgbClr val="E8EDF2"/>
-                </a:solidFill>
-                <a:latin typeface="Arial"/>
-              </a:rPr>
-              <a:t>—   A swap with one leg on BTC and one on a BLAKE2b chain</a:t>
-            </a:r>
-          </a:p>
-          <a:p>
-            <a:pPr>
-              <a:spcAft>
-                <a:spcPts val="1100"/>
-              </a:spcAft>
-            </a:pPr>
-            <a:r>
-              <a:rPr sz="2000" b="0" i="0">
-                <a:solidFill>
-                  <a:srgbClr val="E8EDF2"/>
-                </a:solidFill>
-                <a:latin typeface="Arial"/>
-              </a:rPr>
-              <a:t>—   BKIP-0001 — the specification that did not exist, checked against Knots' own vectors</a:t>
+              <a:t>—   No custody: the exchange relays two parallel legs, holding nothing</a:t>
             </a:r>
           </a:p>
         </p:txBody>
@@ -5192,8 +5517,8 @@
         </p:nvSpPr>
         <p:spPr>
           <a:xfrm>
-            <a:off x="822960" y="5989320"/>
-            <a:ext cx="10515600" cy="457200"/>
+            <a:off x="822960" y="4709160"/>
+            <a:ext cx="10515600" cy="1097280"/>
           </a:xfrm>
           <a:prstGeom prst="rect">
             <a:avLst/>
@@ -5212,13 +5537,52 @@
               </a:spcAft>
             </a:pPr>
             <a:r>
+              <a:rPr sz="4400" b="1" i="0">
+                <a:solidFill>
+                  <a:srgbClr val="7FD8E8"/>
+                </a:solidFill>
+                <a:latin typeface="Arial"/>
+              </a:rPr>
+              <a:t>3.7 seconds</a:t>
+            </a:r>
+          </a:p>
+        </p:txBody>
+      </p:sp>
+      <p:sp>
+        <p:nvSpPr>
+          <p:cNvPr id="7" name="TextBox 6"/>
+          <p:cNvSpPr txBox="1"/>
+          <p:nvPr/>
+        </p:nvSpPr>
+        <p:spPr>
+          <a:xfrm>
+            <a:off x="822960" y="5989320"/>
+            <a:ext cx="10515600" cy="457200"/>
+          </a:xfrm>
+          <a:prstGeom prst="rect">
+            <a:avLst/>
+          </a:prstGeom>
+          <a:noFill/>
+        </p:spPr>
+        <p:txBody>
+          <a:bodyPr wrap="square" lIns="0" rIns="0" tIns="0" bIns="0">
+            <a:spAutoFit/>
+          </a:bodyPr>
+          <a:lstStyle/>
+          <a:p>
+            <a:pPr>
+              <a:spcAft>
+                <a:spcPts val="0"/>
+              </a:spcAft>
+            </a:pPr>
+            <a:r>
               <a:rPr sz="1400" b="0" i="1">
                 <a:solidFill>
                   <a:srgbClr val="8A97A3"/>
                 </a:solidFill>
                 <a:latin typeface="Arial"/>
               </a:rPr>
-              <a:t>And the negative control: without the support, the node stops dead at the fork.</a:t>
+              <a:t>Measured end to end, on regtest — not projected.</a:t>
             </a:r>
           </a:p>
         </p:txBody>
@@ -5319,7 +5683,7 @@
                 </a:solidFill>
                 <a:latin typeface="Arial"/>
               </a:rPr>
-              <a:t>WHERE IT STANDS</a:t>
+              <a:t>PROVEN WHERE IT IS HARDEST</a:t>
             </a:r>
           </a:p>
         </p:txBody>
@@ -5352,14 +5716,13 @@
               </a:spcAft>
             </a:pPr>
             <a:r>
-              <a:rPr sz="3800" b="1" i="0">
+              <a:rPr sz="4000" b="1" i="0">
                 <a:solidFill>
                   <a:srgbClr val="E8EDF2"/>
                 </a:solidFill>
                 <a:latin typeface="Arial"/>
               </a:rPr>
-              <a:t>Fast is demonstrated.
-Safe is not yet.</a:t>
+              <a:t>Across a consensus fork, live</a:t>
             </a:r>
           </a:p>
         </p:txBody>
@@ -5372,7 +5735,7 @@
         </p:nvSpPr>
         <p:spPr>
           <a:xfrm>
-            <a:off x="822960" y="3017520"/>
+            <a:off x="822960" y="2240280"/>
             <a:ext cx="10515600" cy="3840480"/>
           </a:xfrm>
           <a:prstGeom prst="rect">
@@ -5388,7 +5751,39 @@
           <a:p>
             <a:pPr>
               <a:spcAft>
-                <a:spcPts val="1200"/>
+                <a:spcPts val="1100"/>
+              </a:spcAft>
+            </a:pPr>
+            <a:r>
+              <a:rPr sz="1800" b="0" i="0">
+                <a:solidFill>
+                  <a:srgbClr val="8A97A3"/>
+                </a:solidFill>
+                <a:latin typeface="Arial"/>
+              </a:rPr>
+              <a:t>Bitcoin Knots changes the block header: 80 bytes to 164, and a new proof of work.</a:t>
+            </a:r>
+          </a:p>
+          <a:p>
+            <a:pPr>
+              <a:spcAft>
+                <a:spcPts val="1100"/>
+              </a:spcAft>
+            </a:pPr>
+            <a:r>
+              <a:rPr sz="1800" b="0" i="0">
+                <a:solidFill>
+                  <a:srgbClr val="8A97A3"/>
+                </a:solidFill>
+                <a:latin typeface="Arial"/>
+              </a:rPr>
+              <a:t/>
+            </a:r>
+          </a:p>
+          <a:p>
+            <a:pPr>
+              <a:spcAft>
+                <a:spcPts val="1100"/>
               </a:spcAft>
             </a:pPr>
             <a:r>
@@ -5398,13 +5793,13 @@
                 </a:solidFill>
                 <a:latin typeface="Arial"/>
               </a:rPr>
-              <a:t>—   Proven — the happy path, end to end, on both chains, across the fork</a:t>
-            </a:r>
-          </a:p>
-          <a:p>
-            <a:pPr>
-              <a:spcAft>
-                <a:spcPts val="1200"/>
+              <a:t>—   v2 header support through the whole Rust stack</a:t>
+            </a:r>
+          </a:p>
+          <a:p>
+            <a:pPr>
+              <a:spcAft>
+                <a:spcPts val="1100"/>
               </a:spcAft>
             </a:pPr>
             <a:r>
@@ -5414,29 +5809,13 @@
                 </a:solidFill>
                 <a:latin typeface="Arial"/>
               </a:rPr>
-              <a:t>—   Not proven — force closes, HTLC timeouts, on-chain claims</a:t>
-            </a:r>
-          </a:p>
-          <a:p>
-            <a:pPr>
-              <a:spcAft>
-                <a:spcPts val="1200"/>
-              </a:spcAft>
-            </a:pPr>
-            <a:r>
-              <a:rPr sz="1800" b="0" i="0">
-                <a:solidFill>
-                  <a:srgbClr val="8A97A3"/>
-                </a:solidFill>
-                <a:latin typeface="Arial"/>
-              </a:rPr>
-              <a:t/>
-            </a:r>
-          </a:p>
-          <a:p>
-            <a:pPr>
-              <a:spcAft>
-                <a:spcPts val="1200"/>
+              <a:t>—   A node follows the chain across activation without losing a channel</a:t>
+            </a:r>
+          </a:p>
+          <a:p>
+            <a:pPr>
+              <a:spcAft>
+                <a:spcPts val="1100"/>
               </a:spcAft>
             </a:pPr>
             <a:r>
@@ -5446,13 +5825,13 @@
                 </a:solidFill>
                 <a:latin typeface="Arial"/>
               </a:rPr>
-              <a:t>Every scenario so far ends with both parties cooperating. The safety</a:t>
-            </a:r>
-          </a:p>
-          <a:p>
-            <a:pPr>
-              <a:spcAft>
-                <a:spcPts val="1200"/>
+              <a:t>—   A swap with one leg on BTC and one on a BLAKE2b chain</a:t>
+            </a:r>
+          </a:p>
+          <a:p>
+            <a:pPr>
+              <a:spcAft>
+                <a:spcPts val="1100"/>
               </a:spcAft>
             </a:pPr>
             <a:r>
@@ -5462,7 +5841,7 @@
                 </a:solidFill>
                 <a:latin typeface="Arial"/>
               </a:rPr>
-              <a:t>argument rests entirely on what happens when one of them does not.</a:t>
+              <a:t>—   BKIP-0001 — the specification that did not exist, checked against Knots' own vectors</a:t>
             </a:r>
           </a:p>
         </p:txBody>
@@ -5501,7 +5880,7 @@
                 </a:solidFill>
                 <a:latin typeface="Arial"/>
               </a:rPr>
-              <a:t>That is the next mission, and it is deliberately not claimed yet.</a:t>
+              <a:t>And the negative control: without the support, the node stops dead at the fork.</a:t>
             </a:r>
           </a:p>
         </p:txBody>

</xml_diff>

<commit_message>
Frame the deck on the egg
Traditionally a node is built like an egg: a hard shell — TLS,
macaroons, a firewall, a VPN — and inside it the API, the keys and the
policy, together and trusted. Crack the shell once and there is nothing
else to defeat.

This summer operators were afraid of an omelette, and two of the three
incidents were exactly that: a credential that could be stolen and an
interface that could be reached.

The metaphor carries the architecture better than the earlier framing
did, because it names what is actually different here — not a harder
shell, but no soft centre, the part worth stealing having never been
inside it.
</commit_message>
<xml_diff>
--- a/doc/diamond-lightning-node.pptx
+++ b/doc/diamond-lightning-node.pptx
@@ -3730,14 +3730,13 @@
               </a:spcAft>
             </a:pPr>
             <a:r>
-              <a:rPr sz="3800" b="1" i="0">
+              <a:rPr sz="4000" b="1" i="0">
                 <a:solidFill>
                   <a:srgbClr val="E8EDF2"/>
                 </a:solidFill>
                 <a:latin typeface="Arial"/>
               </a:rPr>
-              <a:t>A Lightning node is a hot wallet
-with a web server attached</a:t>
+              <a:t>Traditionally, a node is built like an egg</a:t>
             </a:r>
           </a:p>
         </p:txBody>
@@ -3750,7 +3749,7 @@
         </p:nvSpPr>
         <p:spPr>
           <a:xfrm>
-            <a:off x="822960" y="2880360"/>
+            <a:off x="822960" y="2651760"/>
             <a:ext cx="10515600" cy="3840480"/>
           </a:xfrm>
           <a:prstGeom prst="rect">
@@ -3766,7 +3765,39 @@
           <a:p>
             <a:pPr>
               <a:spcAft>
-                <a:spcPts val="1600"/>
+                <a:spcPts val="1400"/>
+              </a:spcAft>
+            </a:pPr>
+            <a:r>
+              <a:rPr sz="1800" b="0" i="0">
+                <a:solidFill>
+                  <a:srgbClr val="8A97A3"/>
+                </a:solidFill>
+                <a:latin typeface="Arial"/>
+              </a:rPr>
+              <a:t>A hot wallet with a web server attached, behind a single perimeter.</a:t>
+            </a:r>
+          </a:p>
+          <a:p>
+            <a:pPr>
+              <a:spcAft>
+                <a:spcPts val="1400"/>
+              </a:spcAft>
+            </a:pPr>
+            <a:r>
+              <a:rPr sz="1800" b="0" i="0">
+                <a:solidFill>
+                  <a:srgbClr val="8A97A3"/>
+                </a:solidFill>
+                <a:latin typeface="Arial"/>
+              </a:rPr>
+              <a:t/>
+            </a:r>
+          </a:p>
+          <a:p>
+            <a:pPr>
+              <a:spcAft>
+                <a:spcPts val="1400"/>
               </a:spcAft>
             </a:pPr>
             <a:r>
@@ -3776,13 +3807,13 @@
                 </a:solidFill>
                 <a:latin typeface="Arial"/>
               </a:rPr>
-              <a:t>—   REST, gRPC, a CLI, macaroons — inbound surface, always listening</a:t>
-            </a:r>
-          </a:p>
-          <a:p>
-            <a:pPr>
-              <a:spcAft>
-                <a:spcPts val="1600"/>
+              <a:t>—   The shell  —  TLS, macaroons, a firewall, a VPN</a:t>
+            </a:r>
+          </a:p>
+          <a:p>
+            <a:pPr>
+              <a:spcAft>
+                <a:spcPts val="1400"/>
               </a:spcAft>
             </a:pPr>
             <a:r>
@@ -3792,13 +3823,13 @@
                 </a:solidFill>
                 <a:latin typeface="Arial"/>
               </a:rPr>
-              <a:t>—   The node holds the very keys it signs with</a:t>
-            </a:r>
-          </a:p>
-          <a:p>
-            <a:pPr>
-              <a:spcAft>
-                <a:spcPts val="1600"/>
+              <a:t>—   The centre  —  the API, the keys and the policy, together and trusted</a:t>
+            </a:r>
+          </a:p>
+          <a:p>
+            <a:pPr>
+              <a:spcAft>
+                <a:spcPts val="1400"/>
               </a:spcAft>
             </a:pPr>
             <a:r>
@@ -3808,7 +3839,7 @@
                 </a:solidFill>
                 <a:latin typeface="Arial"/>
               </a:rPr>
-              <a:t>—   Whoever controls the node controls the money</a:t>
+              <a:t>—   Crack the shell once, and there is nothing else to defeat</a:t>
             </a:r>
           </a:p>
         </p:txBody>
@@ -3847,7 +3878,7 @@
                 </a:solidFill>
                 <a:latin typeface="Arial"/>
               </a:rPr>
-              <a:t>Every common mitigation is a patch on that shape, not a change to it.</a:t>
+              <a:t>Every common mitigation hardens the shell. None of them changes what is inside it.</a:t>
             </a:r>
           </a:p>
         </p:txBody>
@@ -3981,13 +4012,14 @@
               </a:spcAft>
             </a:pPr>
             <a:r>
-              <a:rPr sz="3400" b="1" i="0">
+              <a:rPr sz="3800" b="1" i="0">
                 <a:solidFill>
                   <a:srgbClr val="E8EDF2"/>
                 </a:solidFill>
                 <a:latin typeface="Arial"/>
               </a:rPr>
-              <a:t>A summer of operators afraid of their own nodes</a:t>
+              <a:t>This summer, operators were afraid
+of an omelette</a:t>
             </a:r>
           </a:p>
         </p:txBody>
@@ -4000,7 +4032,7 @@
         </p:nvSpPr>
         <p:spPr>
           <a:xfrm>
-            <a:off x="822960" y="2148840"/>
+            <a:off x="822960" y="2487168"/>
             <a:ext cx="10515600" cy="3840480"/>
           </a:xfrm>
           <a:prstGeom prst="rect">
@@ -4016,11 +4048,11 @@
           <a:p>
             <a:pPr>
               <a:spcAft>
-                <a:spcPts val="500"/>
-              </a:spcAft>
-            </a:pPr>
-            <a:r>
-              <a:rPr sz="1900" b="1" i="0">
+                <a:spcPts val="400"/>
+              </a:spcAft>
+            </a:pPr>
+            <a:r>
+              <a:rPr sz="1800" b="1" i="0">
                 <a:solidFill>
                   <a:srgbClr val="7FD8E8"/>
                 </a:solidFill>
@@ -4032,11 +4064,11 @@
           <a:p>
             <a:pPr>
               <a:spcAft>
-                <a:spcPts val="500"/>
-              </a:spcAft>
-            </a:pPr>
-            <a:r>
-              <a:rPr sz="1700" b="0" i="0">
+                <a:spcPts val="400"/>
+              </a:spcAft>
+            </a:pPr>
+            <a:r>
+              <a:rPr sz="1600" b="0" i="0">
                 <a:solidFill>
                   <a:srgbClr val="8A97A3"/>
                 </a:solidFill>
@@ -4048,11 +4080,11 @@
           <a:p>
             <a:pPr>
               <a:spcAft>
-                <a:spcPts val="500"/>
-              </a:spcAft>
-            </a:pPr>
-            <a:r>
-              <a:rPr sz="1700" b="0" i="0">
+                <a:spcPts val="400"/>
+              </a:spcAft>
+            </a:pPr>
+            <a:r>
+              <a:rPr sz="1600" b="0" i="0">
                 <a:solidFill>
                   <a:srgbClr val="8A97A3"/>
                 </a:solidFill>
@@ -4064,11 +4096,11 @@
           <a:p>
             <a:pPr>
               <a:spcAft>
-                <a:spcPts val="500"/>
-              </a:spcAft>
-            </a:pPr>
-            <a:r>
-              <a:rPr sz="1700" b="0" i="0">
+                <a:spcPts val="400"/>
+              </a:spcAft>
+            </a:pPr>
+            <a:r>
+              <a:rPr sz="1600" b="0" i="0">
                 <a:solidFill>
                   <a:srgbClr val="8A97A3"/>
                 </a:solidFill>
@@ -4080,11 +4112,11 @@
           <a:p>
             <a:pPr>
               <a:spcAft>
-                <a:spcPts val="500"/>
-              </a:spcAft>
-            </a:pPr>
-            <a:r>
-              <a:rPr sz="1700" b="0" i="0">
+                <a:spcPts val="400"/>
+              </a:spcAft>
+            </a:pPr>
+            <a:r>
+              <a:rPr sz="1600" b="0" i="0">
                 <a:solidFill>
                   <a:srgbClr val="8A97A3"/>
                 </a:solidFill>
@@ -4096,11 +4128,11 @@
           <a:p>
             <a:pPr>
               <a:spcAft>
-                <a:spcPts val="500"/>
-              </a:spcAft>
-            </a:pPr>
-            <a:r>
-              <a:rPr sz="1900" b="1" i="0">
+                <a:spcPts val="400"/>
+              </a:spcAft>
+            </a:pPr>
+            <a:r>
+              <a:rPr sz="1800" b="1" i="0">
                 <a:solidFill>
                   <a:srgbClr val="7FD8E8"/>
                 </a:solidFill>
@@ -4112,11 +4144,11 @@
           <a:p>
             <a:pPr>
               <a:spcAft>
-                <a:spcPts val="500"/>
-              </a:spcAft>
-            </a:pPr>
-            <a:r>
-              <a:rPr sz="1700" b="0" i="0">
+                <a:spcPts val="400"/>
+              </a:spcAft>
+            </a:pPr>
+            <a:r>
+              <a:rPr sz="1600" b="0" i="0">
                 <a:solidFill>
                   <a:srgbClr val="8A97A3"/>
                 </a:solidFill>
@@ -4128,11 +4160,11 @@
           <a:p>
             <a:pPr>
               <a:spcAft>
-                <a:spcPts val="500"/>
-              </a:spcAft>
-            </a:pPr>
-            <a:r>
-              <a:rPr sz="1700" b="0" i="0">
+                <a:spcPts val="400"/>
+              </a:spcAft>
+            </a:pPr>
+            <a:r>
+              <a:rPr sz="1600" b="0" i="0">
                 <a:solidFill>
                   <a:srgbClr val="8A97A3"/>
                 </a:solidFill>
@@ -4144,11 +4176,11 @@
           <a:p>
             <a:pPr>
               <a:spcAft>
-                <a:spcPts val="500"/>
-              </a:spcAft>
-            </a:pPr>
-            <a:r>
-              <a:rPr sz="1700" b="0" i="0">
+                <a:spcPts val="400"/>
+              </a:spcAft>
+            </a:pPr>
+            <a:r>
+              <a:rPr sz="1600" b="0" i="0">
                 <a:solidFill>
                   <a:srgbClr val="8A97A3"/>
                 </a:solidFill>
@@ -4160,11 +4192,11 @@
           <a:p>
             <a:pPr>
               <a:spcAft>
-                <a:spcPts val="500"/>
-              </a:spcAft>
-            </a:pPr>
-            <a:r>
-              <a:rPr sz="1900" b="1" i="0">
+                <a:spcPts val="400"/>
+              </a:spcAft>
+            </a:pPr>
+            <a:r>
+              <a:rPr sz="1800" b="1" i="0">
                 <a:solidFill>
                   <a:srgbClr val="7FD8E8"/>
                 </a:solidFill>
@@ -4176,11 +4208,11 @@
           <a:p>
             <a:pPr>
               <a:spcAft>
-                <a:spcPts val="500"/>
-              </a:spcAft>
-            </a:pPr>
-            <a:r>
-              <a:rPr sz="1700" b="0" i="0">
+                <a:spcPts val="400"/>
+              </a:spcAft>
+            </a:pPr>
+            <a:r>
+              <a:rPr sz="1600" b="0" i="0">
                 <a:solidFill>
                   <a:srgbClr val="8A97A3"/>
                 </a:solidFill>
@@ -4225,7 +4257,7 @@
                 </a:solidFill>
                 <a:latin typeface="Arial"/>
               </a:rPr>
-              <a:t>Two of these are the shape, not the code: a credential that can be stolen, and an interface that can be reached.</a:t>
+              <a:t>Two of the three are the shell, not the code: a credential that could be stolen, and an interface that could be reached.</a:t>
             </a:r>
           </a:p>
         </p:txBody>
@@ -5262,6 +5294,45 @@
                 <a:latin typeface="Arial"/>
               </a:rPr>
               <a:t>—   The signer can run inside an attested secure enclave.</a:t>
+            </a:r>
+          </a:p>
+        </p:txBody>
+      </p:sp>
+      <p:sp>
+        <p:nvSpPr>
+          <p:cNvPr id="6" name="TextBox 5"/>
+          <p:cNvSpPr txBox="1"/>
+          <p:nvPr/>
+        </p:nvSpPr>
+        <p:spPr>
+          <a:xfrm>
+            <a:off x="822960" y="5989320"/>
+            <a:ext cx="10515600" cy="457200"/>
+          </a:xfrm>
+          <a:prstGeom prst="rect">
+            <a:avLst/>
+          </a:prstGeom>
+          <a:noFill/>
+        </p:spPr>
+        <p:txBody>
+          <a:bodyPr wrap="square" lIns="0" rIns="0" tIns="0" bIns="0">
+            <a:spAutoFit/>
+          </a:bodyPr>
+          <a:lstStyle/>
+          <a:p>
+            <a:pPr>
+              <a:spcAft>
+                <a:spcPts val="0"/>
+              </a:spcAft>
+            </a:pPr>
+            <a:r>
+              <a:rPr sz="1400" b="0" i="1">
+                <a:solidFill>
+                  <a:srgbClr val="8A97A3"/>
+                </a:solidFill>
+                <a:latin typeface="Arial"/>
+              </a:rPr>
+              <a:t>There is no soft centre, because the part worth stealing was never inside the shell.</a:t>
             </a:r>
           </a:p>
         </p:txBody>

</xml_diff>